<commit_message>
Corum pitch: styled deck fixes - shrink-to-fit tegen tekst-overloop in PowerPoint + cover logo-botsing opgelost; eigen PIL-renderer voor visuele QA
Co-Authored-By: Claude Opus 4.8 <noreply@anthropic.com>
Claude-Session: https://claude.ai/code/session_01Ve1ndCHgviaGx4xoosLGch
</commit_message>
<xml_diff>
--- a/corum-pitch/Corum-Westgate-I-Pitch-STYLED.pptx
+++ b/corum-pitch/Corum-Westgate-I-Pitch-STYLED.pptx
@@ -3175,7 +3175,7 @@
         </p:spPr>
         <p:txBody>
           <a:bodyPr wrap="square" anchor="t">
-            <a:spAutoFit/>
+            <a:normAutofit/>
           </a:bodyPr>
           <a:lstStyle/>
           <a:p>
@@ -3254,7 +3254,7 @@
         </p:spPr>
         <p:txBody>
           <a:bodyPr wrap="square" anchor="t">
-            <a:spAutoFit/>
+            <a:normAutofit/>
           </a:bodyPr>
           <a:lstStyle/>
           <a:p>
@@ -3289,7 +3289,7 @@
         </p:spPr>
         <p:txBody>
           <a:bodyPr wrap="square" anchor="t">
-            <a:spAutoFit/>
+            <a:normAutofit/>
           </a:bodyPr>
           <a:lstStyle/>
           <a:p>
@@ -3324,7 +3324,7 @@
         </p:spPr>
         <p:txBody>
           <a:bodyPr wrap="square" anchor="t">
-            <a:spAutoFit/>
+            <a:normAutofit/>
           </a:bodyPr>
           <a:lstStyle/>
           <a:p>
@@ -3349,8 +3349,8 @@
         </p:nvSpPr>
         <p:spPr>
           <a:xfrm>
-            <a:off x="10058400" y="5074920"/>
-            <a:ext cx="1645920" cy="822960"/>
+            <a:off x="10241280" y="5806440"/>
+            <a:ext cx="1691640" cy="713232"/>
           </a:xfrm>
           <a:prstGeom prst="rect">
             <a:avLst/>
@@ -3395,8 +3395,8 @@
         </p:nvSpPr>
         <p:spPr>
           <a:xfrm>
-            <a:off x="10058400" y="5349240"/>
-            <a:ext cx="1645920" cy="365760"/>
+            <a:off x="10241280" y="5989320"/>
+            <a:ext cx="1691640" cy="365760"/>
           </a:xfrm>
           <a:prstGeom prst="rect">
             <a:avLst/>
@@ -3405,7 +3405,7 @@
         </p:spPr>
         <p:txBody>
           <a:bodyPr wrap="square" anchor="t">
-            <a:spAutoFit/>
+            <a:normAutofit/>
           </a:bodyPr>
           <a:lstStyle/>
           <a:p>
@@ -3502,7 +3502,7 @@
         </p:spPr>
         <p:txBody>
           <a:bodyPr wrap="square" anchor="t">
-            <a:spAutoFit/>
+            <a:normAutofit/>
           </a:bodyPr>
           <a:lstStyle/>
           <a:p>
@@ -3537,7 +3537,7 @@
         </p:spPr>
         <p:txBody>
           <a:bodyPr wrap="square" anchor="t">
-            <a:spAutoFit/>
+            <a:normAutofit/>
           </a:bodyPr>
           <a:lstStyle/>
           <a:p>
@@ -3584,7 +3584,7 @@
         </p:spPr>
         <p:txBody>
           <a:bodyPr wrap="square" anchor="t">
-            <a:spAutoFit/>
+            <a:normAutofit/>
           </a:bodyPr>
           <a:lstStyle/>
           <a:p>
@@ -3619,7 +3619,7 @@
         </p:spPr>
         <p:txBody>
           <a:bodyPr wrap="square" anchor="t">
-            <a:spAutoFit/>
+            <a:normAutofit/>
           </a:bodyPr>
           <a:lstStyle/>
           <a:p>
@@ -3698,7 +3698,7 @@
         </p:spPr>
         <p:txBody>
           <a:bodyPr wrap="square" anchor="t">
-            <a:spAutoFit/>
+            <a:normAutofit/>
           </a:bodyPr>
           <a:lstStyle/>
           <a:p>
@@ -3733,7 +3733,7 @@
         </p:spPr>
         <p:txBody>
           <a:bodyPr wrap="square" anchor="t">
-            <a:spAutoFit/>
+            <a:normAutofit/>
           </a:bodyPr>
           <a:lstStyle/>
           <a:p>
@@ -3814,7 +3814,7 @@
         </p:spPr>
         <p:txBody>
           <a:bodyPr wrap="square" anchor="t">
-            <a:spAutoFit/>
+            <a:normAutofit/>
           </a:bodyPr>
           <a:lstStyle/>
           <a:p>
@@ -3849,7 +3849,7 @@
         </p:spPr>
         <p:txBody>
           <a:bodyPr wrap="square" anchor="t">
-            <a:spAutoFit/>
+            <a:normAutofit/>
           </a:bodyPr>
           <a:lstStyle/>
           <a:p>
@@ -3930,7 +3930,7 @@
         </p:spPr>
         <p:txBody>
           <a:bodyPr wrap="square" anchor="t">
-            <a:spAutoFit/>
+            <a:normAutofit/>
           </a:bodyPr>
           <a:lstStyle/>
           <a:p>
@@ -3965,7 +3965,7 @@
         </p:spPr>
         <p:txBody>
           <a:bodyPr wrap="square" anchor="t">
-            <a:spAutoFit/>
+            <a:normAutofit/>
           </a:bodyPr>
           <a:lstStyle/>
           <a:p>
@@ -4046,7 +4046,7 @@
         </p:spPr>
         <p:txBody>
           <a:bodyPr wrap="square" anchor="t">
-            <a:spAutoFit/>
+            <a:normAutofit/>
           </a:bodyPr>
           <a:lstStyle/>
           <a:p>
@@ -4081,7 +4081,7 @@
         </p:spPr>
         <p:txBody>
           <a:bodyPr wrap="square" anchor="t">
-            <a:spAutoFit/>
+            <a:normAutofit/>
           </a:bodyPr>
           <a:lstStyle/>
           <a:p>
@@ -4162,7 +4162,7 @@
         </p:spPr>
         <p:txBody>
           <a:bodyPr wrap="square" anchor="t">
-            <a:spAutoFit/>
+            <a:normAutofit/>
           </a:bodyPr>
           <a:lstStyle/>
           <a:p>
@@ -4197,7 +4197,7 @@
         </p:spPr>
         <p:txBody>
           <a:bodyPr wrap="square" anchor="t">
-            <a:spAutoFit/>
+            <a:normAutofit/>
           </a:bodyPr>
           <a:lstStyle/>
           <a:p>
@@ -4294,7 +4294,7 @@
         </p:spPr>
         <p:txBody>
           <a:bodyPr wrap="square" anchor="t">
-            <a:spAutoFit/>
+            <a:normAutofit/>
           </a:bodyPr>
           <a:lstStyle/>
           <a:p>
@@ -4329,7 +4329,7 @@
         </p:spPr>
         <p:txBody>
           <a:bodyPr wrap="square" anchor="t">
-            <a:spAutoFit/>
+            <a:normAutofit/>
           </a:bodyPr>
           <a:lstStyle/>
           <a:p>
@@ -4376,7 +4376,7 @@
         </p:spPr>
         <p:txBody>
           <a:bodyPr wrap="square" anchor="t">
-            <a:spAutoFit/>
+            <a:normAutofit/>
           </a:bodyPr>
           <a:lstStyle/>
           <a:p>
@@ -4411,7 +4411,7 @@
         </p:spPr>
         <p:txBody>
           <a:bodyPr wrap="square" anchor="t">
-            <a:spAutoFit/>
+            <a:normAutofit/>
           </a:bodyPr>
           <a:lstStyle/>
           <a:p>
@@ -4490,7 +4490,7 @@
         </p:spPr>
         <p:txBody>
           <a:bodyPr wrap="square" anchor="t">
-            <a:spAutoFit/>
+            <a:normAutofit/>
           </a:bodyPr>
           <a:lstStyle/>
           <a:p>
@@ -4525,7 +4525,7 @@
         </p:spPr>
         <p:txBody>
           <a:bodyPr wrap="square" anchor="t">
-            <a:spAutoFit/>
+            <a:normAutofit/>
           </a:bodyPr>
           <a:lstStyle/>
           <a:p>
@@ -4652,7 +4652,7 @@
         </p:spPr>
         <p:txBody>
           <a:bodyPr wrap="square" anchor="ctr">
-            <a:spAutoFit/>
+            <a:normAutofit/>
           </a:bodyPr>
           <a:lstStyle/>
           <a:p>
@@ -4687,7 +4687,7 @@
         </p:spPr>
         <p:txBody>
           <a:bodyPr wrap="square" anchor="t">
-            <a:spAutoFit/>
+            <a:normAutofit/>
           </a:bodyPr>
           <a:lstStyle/>
           <a:p>
@@ -4858,7 +4858,7 @@
         </p:spPr>
         <p:txBody>
           <a:bodyPr wrap="square" anchor="ctr">
-            <a:spAutoFit/>
+            <a:normAutofit/>
           </a:bodyPr>
           <a:lstStyle/>
           <a:p>
@@ -4893,7 +4893,7 @@
         </p:spPr>
         <p:txBody>
           <a:bodyPr wrap="square" anchor="t">
-            <a:spAutoFit/>
+            <a:normAutofit/>
           </a:bodyPr>
           <a:lstStyle/>
           <a:p>
@@ -5064,7 +5064,7 @@
         </p:spPr>
         <p:txBody>
           <a:bodyPr wrap="square" anchor="ctr">
-            <a:spAutoFit/>
+            <a:normAutofit/>
           </a:bodyPr>
           <a:lstStyle/>
           <a:p>
@@ -5099,7 +5099,7 @@
         </p:spPr>
         <p:txBody>
           <a:bodyPr wrap="square" anchor="t">
-            <a:spAutoFit/>
+            <a:normAutofit/>
           </a:bodyPr>
           <a:lstStyle/>
           <a:p>
@@ -5270,7 +5270,7 @@
         </p:spPr>
         <p:txBody>
           <a:bodyPr wrap="square" anchor="ctr">
-            <a:spAutoFit/>
+            <a:normAutofit/>
           </a:bodyPr>
           <a:lstStyle/>
           <a:p>
@@ -5305,7 +5305,7 @@
         </p:spPr>
         <p:txBody>
           <a:bodyPr wrap="square" anchor="t">
-            <a:spAutoFit/>
+            <a:normAutofit/>
           </a:bodyPr>
           <a:lstStyle/>
           <a:p>
@@ -5476,7 +5476,7 @@
         </p:spPr>
         <p:txBody>
           <a:bodyPr wrap="square" anchor="ctr">
-            <a:spAutoFit/>
+            <a:normAutofit/>
           </a:bodyPr>
           <a:lstStyle/>
           <a:p>
@@ -5511,7 +5511,7 @@
         </p:spPr>
         <p:txBody>
           <a:bodyPr wrap="square" anchor="t">
-            <a:spAutoFit/>
+            <a:normAutofit/>
           </a:bodyPr>
           <a:lstStyle/>
           <a:p>
@@ -5546,7 +5546,7 @@
         </p:spPr>
         <p:txBody>
           <a:bodyPr wrap="square" anchor="t">
-            <a:spAutoFit/>
+            <a:normAutofit/>
           </a:bodyPr>
           <a:lstStyle/>
           <a:p>
@@ -5643,7 +5643,7 @@
         </p:spPr>
         <p:txBody>
           <a:bodyPr wrap="square" anchor="t">
-            <a:spAutoFit/>
+            <a:normAutofit/>
           </a:bodyPr>
           <a:lstStyle/>
           <a:p>
@@ -5678,7 +5678,7 @@
         </p:spPr>
         <p:txBody>
           <a:bodyPr wrap="square" anchor="t">
-            <a:spAutoFit/>
+            <a:normAutofit/>
           </a:bodyPr>
           <a:lstStyle/>
           <a:p>
@@ -5713,7 +5713,7 @@
         </p:spPr>
         <p:txBody>
           <a:bodyPr wrap="square" anchor="t">
-            <a:spAutoFit/>
+            <a:normAutofit/>
           </a:bodyPr>
           <a:lstStyle/>
           <a:p>
@@ -5748,7 +5748,7 @@
         </p:spPr>
         <p:txBody>
           <a:bodyPr wrap="square" anchor="t">
-            <a:spAutoFit/>
+            <a:normAutofit/>
           </a:bodyPr>
           <a:lstStyle/>
           <a:p>
@@ -5827,7 +5827,7 @@
         </p:spPr>
         <p:txBody>
           <a:bodyPr wrap="square" anchor="t">
-            <a:spAutoFit/>
+            <a:normAutofit/>
           </a:bodyPr>
           <a:lstStyle/>
           <a:p>
@@ -5908,7 +5908,7 @@
         </p:spPr>
         <p:txBody>
           <a:bodyPr wrap="square" anchor="t">
-            <a:spAutoFit/>
+            <a:normAutofit/>
           </a:bodyPr>
           <a:lstStyle/>
           <a:p>
@@ -5943,7 +5943,7 @@
         </p:spPr>
         <p:txBody>
           <a:bodyPr wrap="square" anchor="t">
-            <a:spAutoFit/>
+            <a:normAutofit/>
           </a:bodyPr>
           <a:lstStyle/>
           <a:p>
@@ -6024,7 +6024,7 @@
         </p:spPr>
         <p:txBody>
           <a:bodyPr wrap="square" anchor="t">
-            <a:spAutoFit/>
+            <a:normAutofit/>
           </a:bodyPr>
           <a:lstStyle/>
           <a:p>
@@ -6059,7 +6059,7 @@
         </p:spPr>
         <p:txBody>
           <a:bodyPr wrap="square" anchor="t">
-            <a:spAutoFit/>
+            <a:normAutofit/>
           </a:bodyPr>
           <a:lstStyle/>
           <a:p>
@@ -6140,7 +6140,7 @@
         </p:spPr>
         <p:txBody>
           <a:bodyPr wrap="square" anchor="t">
-            <a:spAutoFit/>
+            <a:normAutofit/>
           </a:bodyPr>
           <a:lstStyle/>
           <a:p>
@@ -6175,7 +6175,7 @@
         </p:spPr>
         <p:txBody>
           <a:bodyPr wrap="square" anchor="t">
-            <a:spAutoFit/>
+            <a:normAutofit/>
           </a:bodyPr>
           <a:lstStyle/>
           <a:p>
@@ -6256,7 +6256,7 @@
         </p:spPr>
         <p:txBody>
           <a:bodyPr wrap="square" anchor="t">
-            <a:spAutoFit/>
+            <a:normAutofit/>
           </a:bodyPr>
           <a:lstStyle/>
           <a:p>
@@ -6291,7 +6291,7 @@
         </p:spPr>
         <p:txBody>
           <a:bodyPr wrap="square" anchor="t">
-            <a:spAutoFit/>
+            <a:normAutofit/>
           </a:bodyPr>
           <a:lstStyle/>
           <a:p>
@@ -6388,7 +6388,7 @@
         </p:spPr>
         <p:txBody>
           <a:bodyPr wrap="square" anchor="t">
-            <a:spAutoFit/>
+            <a:normAutofit/>
           </a:bodyPr>
           <a:lstStyle/>
           <a:p>
@@ -6423,7 +6423,7 @@
         </p:spPr>
         <p:txBody>
           <a:bodyPr wrap="square" anchor="t">
-            <a:spAutoFit/>
+            <a:normAutofit/>
           </a:bodyPr>
           <a:lstStyle/>
           <a:p>
@@ -6470,7 +6470,7 @@
         </p:spPr>
         <p:txBody>
           <a:bodyPr wrap="square" anchor="t">
-            <a:spAutoFit/>
+            <a:normAutofit/>
           </a:bodyPr>
           <a:lstStyle/>
           <a:p>
@@ -6505,7 +6505,7 @@
         </p:spPr>
         <p:txBody>
           <a:bodyPr wrap="square" anchor="t">
-            <a:spAutoFit/>
+            <a:normAutofit/>
           </a:bodyPr>
           <a:lstStyle/>
           <a:p>
@@ -6584,7 +6584,7 @@
         </p:spPr>
         <p:txBody>
           <a:bodyPr wrap="square" anchor="t">
-            <a:spAutoFit/>
+            <a:normAutofit/>
           </a:bodyPr>
           <a:lstStyle/>
           <a:p>
@@ -6709,7 +6709,7 @@
         </p:spPr>
         <p:txBody>
           <a:bodyPr wrap="square" anchor="t">
-            <a:spAutoFit/>
+            <a:normAutofit/>
           </a:bodyPr>
           <a:lstStyle/>
           <a:p>
@@ -6744,7 +6744,7 @@
         </p:spPr>
         <p:txBody>
           <a:bodyPr wrap="square" anchor="t">
-            <a:spAutoFit/>
+            <a:normAutofit/>
           </a:bodyPr>
           <a:lstStyle/>
           <a:p>
@@ -6779,7 +6779,7 @@
         </p:spPr>
         <p:txBody>
           <a:bodyPr wrap="square" anchor="t">
-            <a:spAutoFit/>
+            <a:normAutofit/>
           </a:bodyPr>
           <a:lstStyle/>
           <a:p>
@@ -6860,7 +6860,7 @@
         </p:spPr>
         <p:txBody>
           <a:bodyPr wrap="square" anchor="t">
-            <a:spAutoFit/>
+            <a:normAutofit/>
           </a:bodyPr>
           <a:lstStyle/>
           <a:p>
@@ -6895,7 +6895,7 @@
         </p:spPr>
         <p:txBody>
           <a:bodyPr wrap="square" anchor="t">
-            <a:spAutoFit/>
+            <a:normAutofit/>
           </a:bodyPr>
           <a:lstStyle/>
           <a:p>
@@ -6930,7 +6930,7 @@
         </p:spPr>
         <p:txBody>
           <a:bodyPr wrap="square" anchor="t">
-            <a:spAutoFit/>
+            <a:normAutofit/>
           </a:bodyPr>
           <a:lstStyle/>
           <a:p>
@@ -7011,7 +7011,7 @@
         </p:spPr>
         <p:txBody>
           <a:bodyPr wrap="square" anchor="t">
-            <a:spAutoFit/>
+            <a:normAutofit/>
           </a:bodyPr>
           <a:lstStyle/>
           <a:p>
@@ -7046,7 +7046,7 @@
         </p:spPr>
         <p:txBody>
           <a:bodyPr wrap="square" anchor="t">
-            <a:spAutoFit/>
+            <a:normAutofit/>
           </a:bodyPr>
           <a:lstStyle/>
           <a:p>
@@ -7081,7 +7081,7 @@
         </p:spPr>
         <p:txBody>
           <a:bodyPr wrap="square" anchor="t">
-            <a:spAutoFit/>
+            <a:normAutofit/>
           </a:bodyPr>
           <a:lstStyle/>
           <a:p>
@@ -7162,7 +7162,7 @@
         </p:spPr>
         <p:txBody>
           <a:bodyPr wrap="square" anchor="t">
-            <a:spAutoFit/>
+            <a:normAutofit/>
           </a:bodyPr>
           <a:lstStyle/>
           <a:p>
@@ -7197,7 +7197,7 @@
         </p:spPr>
         <p:txBody>
           <a:bodyPr wrap="square" anchor="t">
-            <a:spAutoFit/>
+            <a:normAutofit/>
           </a:bodyPr>
           <a:lstStyle/>
           <a:p>
@@ -7232,7 +7232,7 @@
         </p:spPr>
         <p:txBody>
           <a:bodyPr wrap="square" anchor="t">
-            <a:spAutoFit/>
+            <a:normAutofit/>
           </a:bodyPr>
           <a:lstStyle/>
           <a:p>
@@ -7313,7 +7313,7 @@
         </p:spPr>
         <p:txBody>
           <a:bodyPr wrap="square" anchor="t">
-            <a:spAutoFit/>
+            <a:normAutofit/>
           </a:bodyPr>
           <a:lstStyle/>
           <a:p>
@@ -7348,7 +7348,7 @@
         </p:spPr>
         <p:txBody>
           <a:bodyPr wrap="square" anchor="t">
-            <a:spAutoFit/>
+            <a:normAutofit/>
           </a:bodyPr>
           <a:lstStyle/>
           <a:p>
@@ -7383,7 +7383,7 @@
         </p:spPr>
         <p:txBody>
           <a:bodyPr wrap="square" anchor="t">
-            <a:spAutoFit/>
+            <a:normAutofit/>
           </a:bodyPr>
           <a:lstStyle/>
           <a:p>
@@ -7464,7 +7464,7 @@
         </p:spPr>
         <p:txBody>
           <a:bodyPr wrap="square" anchor="t">
-            <a:spAutoFit/>
+            <a:normAutofit/>
           </a:bodyPr>
           <a:lstStyle/>
           <a:p>
@@ -7499,7 +7499,7 @@
         </p:spPr>
         <p:txBody>
           <a:bodyPr wrap="square" anchor="t">
-            <a:spAutoFit/>
+            <a:normAutofit/>
           </a:bodyPr>
           <a:lstStyle/>
           <a:p>
@@ -7534,7 +7534,7 @@
         </p:spPr>
         <p:txBody>
           <a:bodyPr wrap="square" anchor="t">
-            <a:spAutoFit/>
+            <a:normAutofit/>
           </a:bodyPr>
           <a:lstStyle/>
           <a:p>
@@ -7569,7 +7569,7 @@
         </p:spPr>
         <p:txBody>
           <a:bodyPr wrap="square" anchor="t">
-            <a:spAutoFit/>
+            <a:normAutofit/>
           </a:bodyPr>
           <a:lstStyle/>
           <a:p>
@@ -7666,7 +7666,7 @@
         </p:spPr>
         <p:txBody>
           <a:bodyPr wrap="square" anchor="t">
-            <a:spAutoFit/>
+            <a:normAutofit/>
           </a:bodyPr>
           <a:lstStyle/>
           <a:p>
@@ -7701,7 +7701,7 @@
         </p:spPr>
         <p:txBody>
           <a:bodyPr wrap="square" anchor="t">
-            <a:spAutoFit/>
+            <a:normAutofit/>
           </a:bodyPr>
           <a:lstStyle/>
           <a:p>
@@ -7736,7 +7736,7 @@
         </p:spPr>
         <p:txBody>
           <a:bodyPr wrap="square" anchor="t">
-            <a:spAutoFit/>
+            <a:normAutofit/>
           </a:bodyPr>
           <a:lstStyle/>
           <a:p>
@@ -7771,7 +7771,7 @@
         </p:spPr>
         <p:txBody>
           <a:bodyPr wrap="square" anchor="t">
-            <a:spAutoFit/>
+            <a:normAutofit/>
           </a:bodyPr>
           <a:lstStyle/>
           <a:p>
@@ -7850,7 +7850,7 @@
         </p:spPr>
         <p:txBody>
           <a:bodyPr wrap="square" anchor="t">
-            <a:spAutoFit/>
+            <a:normAutofit/>
           </a:bodyPr>
           <a:lstStyle/>
           <a:p>
@@ -7977,7 +7977,7 @@
         </p:spPr>
         <p:txBody>
           <a:bodyPr wrap="square" anchor="t">
-            <a:spAutoFit/>
+            <a:normAutofit/>
           </a:bodyPr>
           <a:lstStyle/>
           <a:p>
@@ -8012,7 +8012,7 @@
         </p:spPr>
         <p:txBody>
           <a:bodyPr wrap="square" anchor="t">
-            <a:spAutoFit/>
+            <a:normAutofit/>
           </a:bodyPr>
           <a:lstStyle/>
           <a:p>
@@ -8047,7 +8047,7 @@
         </p:spPr>
         <p:txBody>
           <a:bodyPr wrap="square" anchor="t">
-            <a:spAutoFit/>
+            <a:normAutofit/>
           </a:bodyPr>
           <a:lstStyle/>
           <a:p>
@@ -8218,7 +8218,7 @@
         </p:spPr>
         <p:txBody>
           <a:bodyPr wrap="square" anchor="t">
-            <a:spAutoFit/>
+            <a:normAutofit/>
           </a:bodyPr>
           <a:lstStyle/>
           <a:p>
@@ -8253,7 +8253,7 @@
         </p:spPr>
         <p:txBody>
           <a:bodyPr wrap="square" anchor="t">
-            <a:spAutoFit/>
+            <a:normAutofit/>
           </a:bodyPr>
           <a:lstStyle/>
           <a:p>
@@ -8288,7 +8288,7 @@
         </p:spPr>
         <p:txBody>
           <a:bodyPr wrap="square" anchor="t">
-            <a:spAutoFit/>
+            <a:normAutofit/>
           </a:bodyPr>
           <a:lstStyle/>
           <a:p>
@@ -8459,7 +8459,7 @@
         </p:spPr>
         <p:txBody>
           <a:bodyPr wrap="square" anchor="t">
-            <a:spAutoFit/>
+            <a:normAutofit/>
           </a:bodyPr>
           <a:lstStyle/>
           <a:p>
@@ -8494,7 +8494,7 @@
         </p:spPr>
         <p:txBody>
           <a:bodyPr wrap="square" anchor="t">
-            <a:spAutoFit/>
+            <a:normAutofit/>
           </a:bodyPr>
           <a:lstStyle/>
           <a:p>
@@ -8529,7 +8529,7 @@
         </p:spPr>
         <p:txBody>
           <a:bodyPr wrap="square" anchor="t">
-            <a:spAutoFit/>
+            <a:normAutofit/>
           </a:bodyPr>
           <a:lstStyle/>
           <a:p>
@@ -8700,7 +8700,7 @@
         </p:spPr>
         <p:txBody>
           <a:bodyPr wrap="square" anchor="t">
-            <a:spAutoFit/>
+            <a:normAutofit/>
           </a:bodyPr>
           <a:lstStyle/>
           <a:p>
@@ -8735,7 +8735,7 @@
         </p:spPr>
         <p:txBody>
           <a:bodyPr wrap="square" anchor="t">
-            <a:spAutoFit/>
+            <a:normAutofit/>
           </a:bodyPr>
           <a:lstStyle/>
           <a:p>
@@ -8770,7 +8770,7 @@
         </p:spPr>
         <p:txBody>
           <a:bodyPr wrap="square" anchor="t">
-            <a:spAutoFit/>
+            <a:normAutofit/>
           </a:bodyPr>
           <a:lstStyle/>
           <a:p>
@@ -8851,7 +8851,7 @@
         </p:spPr>
         <p:txBody>
           <a:bodyPr wrap="square" anchor="t">
-            <a:spAutoFit/>
+            <a:normAutofit/>
           </a:bodyPr>
           <a:lstStyle/>
           <a:p>
@@ -8948,7 +8948,7 @@
         </p:spPr>
         <p:txBody>
           <a:bodyPr wrap="square" anchor="t">
-            <a:spAutoFit/>
+            <a:normAutofit/>
           </a:bodyPr>
           <a:lstStyle/>
           <a:p>
@@ -8983,7 +8983,7 @@
         </p:spPr>
         <p:txBody>
           <a:bodyPr wrap="square" anchor="t">
-            <a:spAutoFit/>
+            <a:normAutofit/>
           </a:bodyPr>
           <a:lstStyle/>
           <a:p>
@@ -9018,7 +9018,7 @@
         </p:spPr>
         <p:txBody>
           <a:bodyPr wrap="square" anchor="t">
-            <a:spAutoFit/>
+            <a:normAutofit/>
           </a:bodyPr>
           <a:lstStyle/>
           <a:p>
@@ -9053,7 +9053,7 @@
         </p:spPr>
         <p:txBody>
           <a:bodyPr wrap="square" anchor="t">
-            <a:spAutoFit/>
+            <a:normAutofit/>
           </a:bodyPr>
           <a:lstStyle/>
           <a:p>
@@ -9132,7 +9132,7 @@
         </p:spPr>
         <p:txBody>
           <a:bodyPr wrap="square" anchor="t">
-            <a:spAutoFit/>
+            <a:normAutofit/>
           </a:bodyPr>
           <a:lstStyle/>
           <a:p>
@@ -9167,7 +9167,7 @@
         </p:spPr>
         <p:txBody>
           <a:bodyPr wrap="square" anchor="t">
-            <a:spAutoFit/>
+            <a:normAutofit/>
           </a:bodyPr>
           <a:lstStyle/>
           <a:p>
@@ -9202,7 +9202,7 @@
         </p:spPr>
         <p:txBody>
           <a:bodyPr wrap="square" anchor="t">
-            <a:spAutoFit/>
+            <a:normAutofit/>
           </a:bodyPr>
           <a:lstStyle/>
           <a:p>
@@ -9237,7 +9237,7 @@
         </p:spPr>
         <p:txBody>
           <a:bodyPr wrap="square" anchor="t">
-            <a:spAutoFit/>
+            <a:normAutofit/>
           </a:bodyPr>
           <a:lstStyle/>
           <a:p>
@@ -9272,7 +9272,7 @@
         </p:spPr>
         <p:txBody>
           <a:bodyPr wrap="square" anchor="t">
-            <a:spAutoFit/>
+            <a:normAutofit/>
           </a:bodyPr>
           <a:lstStyle/>
           <a:p>
@@ -9307,7 +9307,7 @@
         </p:spPr>
         <p:txBody>
           <a:bodyPr wrap="square" anchor="t">
-            <a:spAutoFit/>
+            <a:normAutofit/>
           </a:bodyPr>
           <a:lstStyle/>
           <a:p>
@@ -9342,7 +9342,7 @@
         </p:spPr>
         <p:txBody>
           <a:bodyPr wrap="square" anchor="t">
-            <a:spAutoFit/>
+            <a:normAutofit/>
           </a:bodyPr>
           <a:lstStyle/>
           <a:p>
@@ -9377,7 +9377,7 @@
         </p:spPr>
         <p:txBody>
           <a:bodyPr wrap="square" anchor="t">
-            <a:spAutoFit/>
+            <a:normAutofit/>
           </a:bodyPr>
           <a:lstStyle/>
           <a:p>
@@ -9412,7 +9412,7 @@
         </p:spPr>
         <p:txBody>
           <a:bodyPr wrap="square" anchor="t">
-            <a:spAutoFit/>
+            <a:normAutofit/>
           </a:bodyPr>
           <a:lstStyle/>
           <a:p>
@@ -9447,7 +9447,7 @@
         </p:spPr>
         <p:txBody>
           <a:bodyPr wrap="square" anchor="t">
-            <a:spAutoFit/>
+            <a:normAutofit/>
           </a:bodyPr>
           <a:lstStyle/>
           <a:p>
@@ -9526,7 +9526,7 @@
         </p:spPr>
         <p:txBody>
           <a:bodyPr wrap="square" anchor="t">
-            <a:spAutoFit/>
+            <a:normAutofit/>
           </a:bodyPr>
           <a:lstStyle/>
           <a:p>
@@ -9605,7 +9605,7 @@
         </p:spPr>
         <p:txBody>
           <a:bodyPr wrap="square" anchor="t">
-            <a:spAutoFit/>
+            <a:normAutofit/>
           </a:bodyPr>
           <a:lstStyle/>
           <a:p>
@@ -9684,7 +9684,7 @@
         </p:spPr>
         <p:txBody>
           <a:bodyPr wrap="square" anchor="t">
-            <a:spAutoFit/>
+            <a:normAutofit/>
           </a:bodyPr>
           <a:lstStyle/>
           <a:p>
@@ -9763,7 +9763,7 @@
         </p:spPr>
         <p:txBody>
           <a:bodyPr wrap="square" anchor="t">
-            <a:spAutoFit/>
+            <a:normAutofit/>
           </a:bodyPr>
           <a:lstStyle/>
           <a:p>
@@ -9842,7 +9842,7 @@
         </p:spPr>
         <p:txBody>
           <a:bodyPr wrap="square" anchor="t">
-            <a:spAutoFit/>
+            <a:normAutofit/>
           </a:bodyPr>
           <a:lstStyle/>
           <a:p>
@@ -9921,7 +9921,7 @@
         </p:spPr>
         <p:txBody>
           <a:bodyPr wrap="square" anchor="t">
-            <a:spAutoFit/>
+            <a:normAutofit/>
           </a:bodyPr>
           <a:lstStyle/>
           <a:p>
@@ -10000,7 +10000,7 @@
         </p:spPr>
         <p:txBody>
           <a:bodyPr wrap="square" anchor="t">
-            <a:spAutoFit/>
+            <a:normAutofit/>
           </a:bodyPr>
           <a:lstStyle/>
           <a:p>
@@ -10079,7 +10079,7 @@
         </p:spPr>
         <p:txBody>
           <a:bodyPr wrap="square" anchor="t">
-            <a:spAutoFit/>
+            <a:normAutofit/>
           </a:bodyPr>
           <a:lstStyle/>
           <a:p>
@@ -10204,7 +10204,7 @@
         </p:spPr>
         <p:txBody>
           <a:bodyPr wrap="square" anchor="t">
-            <a:spAutoFit/>
+            <a:normAutofit/>
           </a:bodyPr>
           <a:lstStyle/>
           <a:p>
@@ -10239,7 +10239,7 @@
         </p:spPr>
         <p:txBody>
           <a:bodyPr wrap="square" anchor="t">
-            <a:spAutoFit/>
+            <a:normAutofit/>
           </a:bodyPr>
           <a:lstStyle/>
           <a:p>
@@ -10336,7 +10336,7 @@
         </p:spPr>
         <p:txBody>
           <a:bodyPr wrap="square" anchor="t">
-            <a:spAutoFit/>
+            <a:normAutofit/>
           </a:bodyPr>
           <a:lstStyle/>
           <a:p>
@@ -10371,7 +10371,7 @@
         </p:spPr>
         <p:txBody>
           <a:bodyPr wrap="square" anchor="t">
-            <a:spAutoFit/>
+            <a:normAutofit/>
           </a:bodyPr>
           <a:lstStyle/>
           <a:p>
@@ -10418,7 +10418,7 @@
         </p:spPr>
         <p:txBody>
           <a:bodyPr wrap="square" anchor="t">
-            <a:spAutoFit/>
+            <a:normAutofit/>
           </a:bodyPr>
           <a:lstStyle/>
           <a:p>
@@ -10453,7 +10453,7 @@
         </p:spPr>
         <p:txBody>
           <a:bodyPr wrap="square" anchor="t">
-            <a:spAutoFit/>
+            <a:normAutofit/>
           </a:bodyPr>
           <a:lstStyle/>
           <a:p>
@@ -10532,7 +10532,7 @@
         </p:spPr>
         <p:txBody>
           <a:bodyPr wrap="square" anchor="t">
-            <a:spAutoFit/>
+            <a:normAutofit/>
           </a:bodyPr>
           <a:lstStyle/>
           <a:p>
@@ -10613,7 +10613,7 @@
         </p:spPr>
         <p:txBody>
           <a:bodyPr wrap="square" anchor="ctr">
-            <a:spAutoFit/>
+            <a:normAutofit/>
           </a:bodyPr>
           <a:lstStyle/>
           <a:p>
@@ -10706,7 +10706,7 @@
         </p:spPr>
         <p:txBody>
           <a:bodyPr wrap="square" anchor="ctr">
-            <a:spAutoFit/>
+            <a:normAutofit/>
           </a:bodyPr>
           <a:lstStyle/>
           <a:p>
@@ -10799,7 +10799,7 @@
         </p:spPr>
         <p:txBody>
           <a:bodyPr wrap="square" anchor="ctr">
-            <a:spAutoFit/>
+            <a:normAutofit/>
           </a:bodyPr>
           <a:lstStyle/>
           <a:p>
@@ -10904,7 +10904,7 @@
         </p:spPr>
         <p:txBody>
           <a:bodyPr wrap="square" anchor="ctr">
-            <a:spAutoFit/>
+            <a:normAutofit/>
           </a:bodyPr>
           <a:lstStyle/>
           <a:p>
@@ -11021,7 +11021,7 @@
         </p:spPr>
         <p:txBody>
           <a:bodyPr wrap="square" anchor="ctr">
-            <a:spAutoFit/>
+            <a:normAutofit/>
           </a:bodyPr>
           <a:lstStyle/>
           <a:p>
@@ -11114,7 +11114,7 @@
         </p:spPr>
         <p:txBody>
           <a:bodyPr wrap="square" anchor="ctr">
-            <a:spAutoFit/>
+            <a:normAutofit/>
           </a:bodyPr>
           <a:lstStyle/>
           <a:p>
@@ -11207,7 +11207,7 @@
         </p:spPr>
         <p:txBody>
           <a:bodyPr wrap="square" anchor="t">
-            <a:spAutoFit/>
+            <a:normAutofit/>
           </a:bodyPr>
           <a:lstStyle/>
           <a:p>
@@ -11304,7 +11304,7 @@
         </p:spPr>
         <p:txBody>
           <a:bodyPr wrap="square" anchor="t">
-            <a:spAutoFit/>
+            <a:normAutofit/>
           </a:bodyPr>
           <a:lstStyle/>
           <a:p>
@@ -11339,7 +11339,7 @@
         </p:spPr>
         <p:txBody>
           <a:bodyPr wrap="square" anchor="t">
-            <a:spAutoFit/>
+            <a:normAutofit/>
           </a:bodyPr>
           <a:lstStyle/>
           <a:p>
@@ -11386,7 +11386,7 @@
         </p:spPr>
         <p:txBody>
           <a:bodyPr wrap="square" anchor="t">
-            <a:spAutoFit/>
+            <a:normAutofit/>
           </a:bodyPr>
           <a:lstStyle/>
           <a:p>
@@ -11421,7 +11421,7 @@
         </p:spPr>
         <p:txBody>
           <a:bodyPr wrap="square" anchor="t">
-            <a:spAutoFit/>
+            <a:normAutofit/>
           </a:bodyPr>
           <a:lstStyle/>
           <a:p>
@@ -11500,7 +11500,7 @@
         </p:spPr>
         <p:txBody>
           <a:bodyPr wrap="square" anchor="t">
-            <a:spAutoFit/>
+            <a:normAutofit/>
           </a:bodyPr>
           <a:lstStyle/>
           <a:p>
@@ -11581,7 +11581,7 @@
         </p:spPr>
         <p:txBody>
           <a:bodyPr wrap="square" anchor="t">
-            <a:spAutoFit/>
+            <a:normAutofit/>
           </a:bodyPr>
           <a:lstStyle/>
           <a:p>
@@ -11662,7 +11662,7 @@
         </p:spPr>
         <p:txBody>
           <a:bodyPr wrap="square" anchor="t">
-            <a:spAutoFit/>
+            <a:normAutofit/>
           </a:bodyPr>
           <a:lstStyle/>
           <a:p>
@@ -11743,7 +11743,7 @@
         </p:spPr>
         <p:txBody>
           <a:bodyPr wrap="square" anchor="t">
-            <a:spAutoFit/>
+            <a:normAutofit/>
           </a:bodyPr>
           <a:lstStyle/>
           <a:p>
@@ -11824,7 +11824,7 @@
         </p:spPr>
         <p:txBody>
           <a:bodyPr wrap="square" anchor="t">
-            <a:spAutoFit/>
+            <a:normAutofit/>
           </a:bodyPr>
           <a:lstStyle/>
           <a:p>
@@ -11905,7 +11905,7 @@
         </p:spPr>
         <p:txBody>
           <a:bodyPr wrap="square" anchor="t">
-            <a:spAutoFit/>
+            <a:normAutofit/>
           </a:bodyPr>
           <a:lstStyle/>
           <a:p>
@@ -11986,7 +11986,7 @@
         </p:spPr>
         <p:txBody>
           <a:bodyPr wrap="square" anchor="ctr">
-            <a:spAutoFit/>
+            <a:normAutofit/>
           </a:bodyPr>
           <a:lstStyle/>
           <a:p>
@@ -12067,7 +12067,7 @@
         </p:spPr>
         <p:txBody>
           <a:bodyPr wrap="square" anchor="ctr">
-            <a:spAutoFit/>
+            <a:normAutofit/>
           </a:bodyPr>
           <a:lstStyle/>
           <a:p>
@@ -12148,7 +12148,7 @@
         </p:spPr>
         <p:txBody>
           <a:bodyPr wrap="square" anchor="ctr">
-            <a:spAutoFit/>
+            <a:normAutofit/>
           </a:bodyPr>
           <a:lstStyle/>
           <a:p>
@@ -12229,7 +12229,7 @@
         </p:spPr>
         <p:txBody>
           <a:bodyPr wrap="square" anchor="ctr">
-            <a:spAutoFit/>
+            <a:normAutofit/>
           </a:bodyPr>
           <a:lstStyle/>
           <a:p>
@@ -12310,7 +12310,7 @@
         </p:spPr>
         <p:txBody>
           <a:bodyPr wrap="square" anchor="ctr">
-            <a:spAutoFit/>
+            <a:normAutofit/>
           </a:bodyPr>
           <a:lstStyle/>
           <a:p>
@@ -12391,7 +12391,7 @@
         </p:spPr>
         <p:txBody>
           <a:bodyPr wrap="square" anchor="ctr">
-            <a:spAutoFit/>
+            <a:normAutofit/>
           </a:bodyPr>
           <a:lstStyle/>
           <a:p>
@@ -12472,7 +12472,7 @@
         </p:spPr>
         <p:txBody>
           <a:bodyPr wrap="square" anchor="ctr">
-            <a:spAutoFit/>
+            <a:normAutofit/>
           </a:bodyPr>
           <a:lstStyle/>
           <a:p>
@@ -12553,7 +12553,7 @@
         </p:spPr>
         <p:txBody>
           <a:bodyPr wrap="square" anchor="ctr">
-            <a:spAutoFit/>
+            <a:normAutofit/>
           </a:bodyPr>
           <a:lstStyle/>
           <a:p>
@@ -12634,7 +12634,7 @@
         </p:spPr>
         <p:txBody>
           <a:bodyPr wrap="square" anchor="ctr">
-            <a:spAutoFit/>
+            <a:normAutofit/>
           </a:bodyPr>
           <a:lstStyle/>
           <a:p>
@@ -12715,7 +12715,7 @@
         </p:spPr>
         <p:txBody>
           <a:bodyPr wrap="square" anchor="ctr">
-            <a:spAutoFit/>
+            <a:normAutofit/>
           </a:bodyPr>
           <a:lstStyle/>
           <a:p>
@@ -12796,7 +12796,7 @@
         </p:spPr>
         <p:txBody>
           <a:bodyPr wrap="square" anchor="ctr">
-            <a:spAutoFit/>
+            <a:normAutofit/>
           </a:bodyPr>
           <a:lstStyle/>
           <a:p>
@@ -12877,7 +12877,7 @@
         </p:spPr>
         <p:txBody>
           <a:bodyPr wrap="square" anchor="ctr">
-            <a:spAutoFit/>
+            <a:normAutofit/>
           </a:bodyPr>
           <a:lstStyle/>
           <a:p>
@@ -12958,7 +12958,7 @@
         </p:spPr>
         <p:txBody>
           <a:bodyPr wrap="square" anchor="ctr">
-            <a:spAutoFit/>
+            <a:normAutofit/>
           </a:bodyPr>
           <a:lstStyle/>
           <a:p>
@@ -13039,7 +13039,7 @@
         </p:spPr>
         <p:txBody>
           <a:bodyPr wrap="square" anchor="ctr">
-            <a:spAutoFit/>
+            <a:normAutofit/>
           </a:bodyPr>
           <a:lstStyle/>
           <a:p>
@@ -13120,7 +13120,7 @@
         </p:spPr>
         <p:txBody>
           <a:bodyPr wrap="square" anchor="ctr">
-            <a:spAutoFit/>
+            <a:normAutofit/>
           </a:bodyPr>
           <a:lstStyle/>
           <a:p>
@@ -13201,7 +13201,7 @@
         </p:spPr>
         <p:txBody>
           <a:bodyPr wrap="square" anchor="ctr">
-            <a:spAutoFit/>
+            <a:normAutofit/>
           </a:bodyPr>
           <a:lstStyle/>
           <a:p>
@@ -13282,7 +13282,7 @@
         </p:spPr>
         <p:txBody>
           <a:bodyPr wrap="square" anchor="ctr">
-            <a:spAutoFit/>
+            <a:normAutofit/>
           </a:bodyPr>
           <a:lstStyle/>
           <a:p>
@@ -13363,7 +13363,7 @@
         </p:spPr>
         <p:txBody>
           <a:bodyPr wrap="square" anchor="ctr">
-            <a:spAutoFit/>
+            <a:normAutofit/>
           </a:bodyPr>
           <a:lstStyle/>
           <a:p>
@@ -13444,7 +13444,7 @@
         </p:spPr>
         <p:txBody>
           <a:bodyPr wrap="square" anchor="ctr">
-            <a:spAutoFit/>
+            <a:normAutofit/>
           </a:bodyPr>
           <a:lstStyle/>
           <a:p>
@@ -13525,7 +13525,7 @@
         </p:spPr>
         <p:txBody>
           <a:bodyPr wrap="square" anchor="ctr">
-            <a:spAutoFit/>
+            <a:normAutofit/>
           </a:bodyPr>
           <a:lstStyle/>
           <a:p>
@@ -13606,7 +13606,7 @@
         </p:spPr>
         <p:txBody>
           <a:bodyPr wrap="square" anchor="ctr">
-            <a:spAutoFit/>
+            <a:normAutofit/>
           </a:bodyPr>
           <a:lstStyle/>
           <a:p>
@@ -13687,7 +13687,7 @@
         </p:spPr>
         <p:txBody>
           <a:bodyPr wrap="square" anchor="ctr">
-            <a:spAutoFit/>
+            <a:normAutofit/>
           </a:bodyPr>
           <a:lstStyle/>
           <a:p>
@@ -13768,7 +13768,7 @@
         </p:spPr>
         <p:txBody>
           <a:bodyPr wrap="square" anchor="ctr">
-            <a:spAutoFit/>
+            <a:normAutofit/>
           </a:bodyPr>
           <a:lstStyle/>
           <a:p>
@@ -13849,7 +13849,7 @@
         </p:spPr>
         <p:txBody>
           <a:bodyPr wrap="square" anchor="ctr">
-            <a:spAutoFit/>
+            <a:normAutofit/>
           </a:bodyPr>
           <a:lstStyle/>
           <a:p>
@@ -13930,7 +13930,7 @@
         </p:spPr>
         <p:txBody>
           <a:bodyPr wrap="square" anchor="ctr">
-            <a:spAutoFit/>
+            <a:normAutofit/>
           </a:bodyPr>
           <a:lstStyle/>
           <a:p>
@@ -14011,7 +14011,7 @@
         </p:spPr>
         <p:txBody>
           <a:bodyPr wrap="square" anchor="ctr">
-            <a:spAutoFit/>
+            <a:normAutofit/>
           </a:bodyPr>
           <a:lstStyle/>
           <a:p>
@@ -14092,7 +14092,7 @@
         </p:spPr>
         <p:txBody>
           <a:bodyPr wrap="square" anchor="ctr">
-            <a:spAutoFit/>
+            <a:normAutofit/>
           </a:bodyPr>
           <a:lstStyle/>
           <a:p>
@@ -14173,7 +14173,7 @@
         </p:spPr>
         <p:txBody>
           <a:bodyPr wrap="square" anchor="ctr">
-            <a:spAutoFit/>
+            <a:normAutofit/>
           </a:bodyPr>
           <a:lstStyle/>
           <a:p>
@@ -14254,7 +14254,7 @@
         </p:spPr>
         <p:txBody>
           <a:bodyPr wrap="square" anchor="ctr">
-            <a:spAutoFit/>
+            <a:normAutofit/>
           </a:bodyPr>
           <a:lstStyle/>
           <a:p>
@@ -14335,7 +14335,7 @@
         </p:spPr>
         <p:txBody>
           <a:bodyPr wrap="square" anchor="ctr">
-            <a:spAutoFit/>
+            <a:normAutofit/>
           </a:bodyPr>
           <a:lstStyle/>
           <a:p>
@@ -14370,7 +14370,7 @@
         </p:spPr>
         <p:txBody>
           <a:bodyPr wrap="square" anchor="t">
-            <a:spAutoFit/>
+            <a:normAutofit/>
           </a:bodyPr>
           <a:lstStyle/>
           <a:p>
@@ -14467,7 +14467,7 @@
         </p:spPr>
         <p:txBody>
           <a:bodyPr wrap="square" anchor="t">
-            <a:spAutoFit/>
+            <a:normAutofit/>
           </a:bodyPr>
           <a:lstStyle/>
           <a:p>
@@ -14502,7 +14502,7 @@
         </p:spPr>
         <p:txBody>
           <a:bodyPr wrap="square" anchor="t">
-            <a:spAutoFit/>
+            <a:normAutofit/>
           </a:bodyPr>
           <a:lstStyle/>
           <a:p>
@@ -14537,7 +14537,7 @@
         </p:spPr>
         <p:txBody>
           <a:bodyPr wrap="square" anchor="t">
-            <a:spAutoFit/>
+            <a:normAutofit/>
           </a:bodyPr>
           <a:lstStyle/>
           <a:p>
@@ -14572,7 +14572,7 @@
         </p:spPr>
         <p:txBody>
           <a:bodyPr wrap="square" anchor="t">
-            <a:spAutoFit/>
+            <a:normAutofit/>
           </a:bodyPr>
           <a:lstStyle/>
           <a:p>
@@ -14651,7 +14651,7 @@
         </p:spPr>
         <p:txBody>
           <a:bodyPr wrap="square" anchor="t">
-            <a:spAutoFit/>
+            <a:normAutofit/>
           </a:bodyPr>
           <a:lstStyle/>
           <a:p>
@@ -14686,7 +14686,7 @@
         </p:spPr>
         <p:txBody>
           <a:bodyPr wrap="square" anchor="t">
-            <a:spAutoFit/>
+            <a:normAutofit/>
           </a:bodyPr>
           <a:lstStyle/>
           <a:p>
@@ -14915,7 +14915,7 @@
         </p:spPr>
         <p:txBody>
           <a:bodyPr wrap="square" anchor="t">
-            <a:spAutoFit/>
+            <a:normAutofit/>
           </a:bodyPr>
           <a:lstStyle/>
           <a:p>
@@ -14996,7 +14996,7 @@
         </p:spPr>
         <p:txBody>
           <a:bodyPr wrap="square" anchor="t">
-            <a:spAutoFit/>
+            <a:normAutofit/>
           </a:bodyPr>
           <a:lstStyle/>
           <a:p>
@@ -15031,7 +15031,7 @@
         </p:spPr>
         <p:txBody>
           <a:bodyPr wrap="square" anchor="t">
-            <a:spAutoFit/>
+            <a:normAutofit/>
           </a:bodyPr>
           <a:lstStyle/>
           <a:p>
@@ -15066,7 +15066,7 @@
         </p:spPr>
         <p:txBody>
           <a:bodyPr wrap="square" anchor="t">
-            <a:spAutoFit/>
+            <a:normAutofit/>
           </a:bodyPr>
           <a:lstStyle/>
           <a:p>
@@ -15147,7 +15147,7 @@
         </p:spPr>
         <p:txBody>
           <a:bodyPr wrap="square" anchor="t">
-            <a:spAutoFit/>
+            <a:normAutofit/>
           </a:bodyPr>
           <a:lstStyle/>
           <a:p>
@@ -15182,7 +15182,7 @@
         </p:spPr>
         <p:txBody>
           <a:bodyPr wrap="square" anchor="t">
-            <a:spAutoFit/>
+            <a:normAutofit/>
           </a:bodyPr>
           <a:lstStyle/>
           <a:p>
@@ -15217,7 +15217,7 @@
         </p:spPr>
         <p:txBody>
           <a:bodyPr wrap="square" anchor="t">
-            <a:spAutoFit/>
+            <a:normAutofit/>
           </a:bodyPr>
           <a:lstStyle/>
           <a:p>
@@ -15298,7 +15298,7 @@
         </p:spPr>
         <p:txBody>
           <a:bodyPr wrap="square" anchor="t">
-            <a:spAutoFit/>
+            <a:normAutofit/>
           </a:bodyPr>
           <a:lstStyle/>
           <a:p>
@@ -15333,7 +15333,7 @@
         </p:spPr>
         <p:txBody>
           <a:bodyPr wrap="square" anchor="t">
-            <a:spAutoFit/>
+            <a:normAutofit/>
           </a:bodyPr>
           <a:lstStyle/>
           <a:p>
@@ -15368,7 +15368,7 @@
         </p:spPr>
         <p:txBody>
           <a:bodyPr wrap="square" anchor="t">
-            <a:spAutoFit/>
+            <a:normAutofit/>
           </a:bodyPr>
           <a:lstStyle/>
           <a:p>
@@ -15449,7 +15449,7 @@
         </p:spPr>
         <p:txBody>
           <a:bodyPr wrap="square" anchor="t">
-            <a:spAutoFit/>
+            <a:normAutofit/>
           </a:bodyPr>
           <a:lstStyle/>
           <a:p>
@@ -15484,7 +15484,7 @@
         </p:spPr>
         <p:txBody>
           <a:bodyPr wrap="square" anchor="t">
-            <a:spAutoFit/>
+            <a:normAutofit/>
           </a:bodyPr>
           <a:lstStyle/>
           <a:p>
@@ -15519,7 +15519,7 @@
         </p:spPr>
         <p:txBody>
           <a:bodyPr wrap="square" anchor="t">
-            <a:spAutoFit/>
+            <a:normAutofit/>
           </a:bodyPr>
           <a:lstStyle/>
           <a:p>
@@ -15600,7 +15600,7 @@
         </p:spPr>
         <p:txBody>
           <a:bodyPr wrap="square" anchor="t">
-            <a:spAutoFit/>
+            <a:normAutofit/>
           </a:bodyPr>
           <a:lstStyle/>
           <a:p>
@@ -15635,7 +15635,7 @@
         </p:spPr>
         <p:txBody>
           <a:bodyPr wrap="square" anchor="t">
-            <a:spAutoFit/>
+            <a:normAutofit/>
           </a:bodyPr>
           <a:lstStyle/>
           <a:p>
@@ -15670,7 +15670,7 @@
         </p:spPr>
         <p:txBody>
           <a:bodyPr wrap="square" anchor="t">
-            <a:spAutoFit/>
+            <a:normAutofit/>
           </a:bodyPr>
           <a:lstStyle/>
           <a:p>
@@ -15751,7 +15751,7 @@
         </p:spPr>
         <p:txBody>
           <a:bodyPr wrap="square" anchor="t">
-            <a:spAutoFit/>
+            <a:normAutofit/>
           </a:bodyPr>
           <a:lstStyle/>
           <a:p>
@@ -15786,7 +15786,7 @@
         </p:spPr>
         <p:txBody>
           <a:bodyPr wrap="square" anchor="t">
-            <a:spAutoFit/>
+            <a:normAutofit/>
           </a:bodyPr>
           <a:lstStyle/>
           <a:p>
@@ -15821,7 +15821,7 @@
         </p:spPr>
         <p:txBody>
           <a:bodyPr wrap="square" anchor="t">
-            <a:spAutoFit/>
+            <a:normAutofit/>
           </a:bodyPr>
           <a:lstStyle/>
           <a:p>
@@ -15918,7 +15918,7 @@
         </p:spPr>
         <p:txBody>
           <a:bodyPr wrap="square" anchor="t">
-            <a:spAutoFit/>
+            <a:normAutofit/>
           </a:bodyPr>
           <a:lstStyle/>
           <a:p>
@@ -15953,7 +15953,7 @@
         </p:spPr>
         <p:txBody>
           <a:bodyPr wrap="square" anchor="t">
-            <a:spAutoFit/>
+            <a:normAutofit/>
           </a:bodyPr>
           <a:lstStyle/>
           <a:p>
@@ -15988,7 +15988,7 @@
         </p:spPr>
         <p:txBody>
           <a:bodyPr wrap="square" anchor="t">
-            <a:spAutoFit/>
+            <a:normAutofit/>
           </a:bodyPr>
           <a:lstStyle/>
           <a:p>
@@ -16023,7 +16023,7 @@
         </p:spPr>
         <p:txBody>
           <a:bodyPr wrap="square" anchor="t">
-            <a:spAutoFit/>
+            <a:normAutofit/>
           </a:bodyPr>
           <a:lstStyle/>
           <a:p>
@@ -16102,7 +16102,7 @@
         </p:spPr>
         <p:txBody>
           <a:bodyPr wrap="square" anchor="t">
-            <a:spAutoFit/>
+            <a:normAutofit/>
           </a:bodyPr>
           <a:lstStyle/>
           <a:p>
@@ -16137,7 +16137,7 @@
         </p:spPr>
         <p:txBody>
           <a:bodyPr wrap="square" anchor="t">
-            <a:spAutoFit/>
+            <a:normAutofit/>
           </a:bodyPr>
           <a:lstStyle/>
           <a:p>
@@ -16218,7 +16218,7 @@
         </p:spPr>
         <p:txBody>
           <a:bodyPr wrap="square" anchor="t">
-            <a:spAutoFit/>
+            <a:normAutofit/>
           </a:bodyPr>
           <a:lstStyle/>
           <a:p>
@@ -16299,7 +16299,7 @@
         </p:spPr>
         <p:txBody>
           <a:bodyPr wrap="square" anchor="t">
-            <a:spAutoFit/>
+            <a:normAutofit/>
           </a:bodyPr>
           <a:lstStyle/>
           <a:p>
@@ -16380,7 +16380,7 @@
         </p:spPr>
         <p:txBody>
           <a:bodyPr wrap="square" anchor="t">
-            <a:spAutoFit/>
+            <a:normAutofit/>
           </a:bodyPr>
           <a:lstStyle/>
           <a:p>
@@ -16461,7 +16461,7 @@
         </p:spPr>
         <p:txBody>
           <a:bodyPr wrap="square" anchor="t">
-            <a:spAutoFit/>
+            <a:normAutofit/>
           </a:bodyPr>
           <a:lstStyle/>
           <a:p>
@@ -16542,7 +16542,7 @@
         </p:spPr>
         <p:txBody>
           <a:bodyPr wrap="square" anchor="t">
-            <a:spAutoFit/>
+            <a:normAutofit/>
           </a:bodyPr>
           <a:lstStyle/>
           <a:p>
@@ -16623,7 +16623,7 @@
         </p:spPr>
         <p:txBody>
           <a:bodyPr wrap="square" anchor="t">
-            <a:spAutoFit/>
+            <a:normAutofit/>
           </a:bodyPr>
           <a:lstStyle/>
           <a:p>
@@ -16704,7 +16704,7 @@
         </p:spPr>
         <p:txBody>
           <a:bodyPr wrap="square" anchor="ctr">
-            <a:spAutoFit/>
+            <a:normAutofit/>
           </a:bodyPr>
           <a:lstStyle/>
           <a:p>
@@ -16785,7 +16785,7 @@
         </p:spPr>
         <p:txBody>
           <a:bodyPr wrap="square" anchor="ctr">
-            <a:spAutoFit/>
+            <a:normAutofit/>
           </a:bodyPr>
           <a:lstStyle/>
           <a:p>
@@ -16866,7 +16866,7 @@
         </p:spPr>
         <p:txBody>
           <a:bodyPr wrap="square" anchor="ctr">
-            <a:spAutoFit/>
+            <a:normAutofit/>
           </a:bodyPr>
           <a:lstStyle/>
           <a:p>
@@ -16947,7 +16947,7 @@
         </p:spPr>
         <p:txBody>
           <a:bodyPr wrap="square" anchor="ctr">
-            <a:spAutoFit/>
+            <a:normAutofit/>
           </a:bodyPr>
           <a:lstStyle/>
           <a:p>
@@ -17028,7 +17028,7 @@
         </p:spPr>
         <p:txBody>
           <a:bodyPr wrap="square" anchor="ctr">
-            <a:spAutoFit/>
+            <a:normAutofit/>
           </a:bodyPr>
           <a:lstStyle/>
           <a:p>
@@ -17109,7 +17109,7 @@
         </p:spPr>
         <p:txBody>
           <a:bodyPr wrap="square" anchor="ctr">
-            <a:spAutoFit/>
+            <a:normAutofit/>
           </a:bodyPr>
           <a:lstStyle/>
           <a:p>
@@ -17190,7 +17190,7 @@
         </p:spPr>
         <p:txBody>
           <a:bodyPr wrap="square" anchor="ctr">
-            <a:spAutoFit/>
+            <a:normAutofit/>
           </a:bodyPr>
           <a:lstStyle/>
           <a:p>
@@ -17271,7 +17271,7 @@
         </p:spPr>
         <p:txBody>
           <a:bodyPr wrap="square" anchor="ctr">
-            <a:spAutoFit/>
+            <a:normAutofit/>
           </a:bodyPr>
           <a:lstStyle/>
           <a:p>
@@ -17352,7 +17352,7 @@
         </p:spPr>
         <p:txBody>
           <a:bodyPr wrap="square" anchor="ctr">
-            <a:spAutoFit/>
+            <a:normAutofit/>
           </a:bodyPr>
           <a:lstStyle/>
           <a:p>
@@ -17433,7 +17433,7 @@
         </p:spPr>
         <p:txBody>
           <a:bodyPr wrap="square" anchor="ctr">
-            <a:spAutoFit/>
+            <a:normAutofit/>
           </a:bodyPr>
           <a:lstStyle/>
           <a:p>
@@ -17514,7 +17514,7 @@
         </p:spPr>
         <p:txBody>
           <a:bodyPr wrap="square" anchor="ctr">
-            <a:spAutoFit/>
+            <a:normAutofit/>
           </a:bodyPr>
           <a:lstStyle/>
           <a:p>
@@ -17595,7 +17595,7 @@
         </p:spPr>
         <p:txBody>
           <a:bodyPr wrap="square" anchor="ctr">
-            <a:spAutoFit/>
+            <a:normAutofit/>
           </a:bodyPr>
           <a:lstStyle/>
           <a:p>
@@ -17676,7 +17676,7 @@
         </p:spPr>
         <p:txBody>
           <a:bodyPr wrap="square" anchor="ctr">
-            <a:spAutoFit/>
+            <a:normAutofit/>
           </a:bodyPr>
           <a:lstStyle/>
           <a:p>
@@ -17757,7 +17757,7 @@
         </p:spPr>
         <p:txBody>
           <a:bodyPr wrap="square" anchor="ctr">
-            <a:spAutoFit/>
+            <a:normAutofit/>
           </a:bodyPr>
           <a:lstStyle/>
           <a:p>
@@ -17838,7 +17838,7 @@
         </p:spPr>
         <p:txBody>
           <a:bodyPr wrap="square" anchor="ctr">
-            <a:spAutoFit/>
+            <a:normAutofit/>
           </a:bodyPr>
           <a:lstStyle/>
           <a:p>
@@ -17919,7 +17919,7 @@
         </p:spPr>
         <p:txBody>
           <a:bodyPr wrap="square" anchor="ctr">
-            <a:spAutoFit/>
+            <a:normAutofit/>
           </a:bodyPr>
           <a:lstStyle/>
           <a:p>
@@ -18000,7 +18000,7 @@
         </p:spPr>
         <p:txBody>
           <a:bodyPr wrap="square" anchor="ctr">
-            <a:spAutoFit/>
+            <a:normAutofit/>
           </a:bodyPr>
           <a:lstStyle/>
           <a:p>
@@ -18081,7 +18081,7 @@
         </p:spPr>
         <p:txBody>
           <a:bodyPr wrap="square" anchor="ctr">
-            <a:spAutoFit/>
+            <a:normAutofit/>
           </a:bodyPr>
           <a:lstStyle/>
           <a:p>
@@ -18162,7 +18162,7 @@
         </p:spPr>
         <p:txBody>
           <a:bodyPr wrap="square" anchor="ctr">
-            <a:spAutoFit/>
+            <a:normAutofit/>
           </a:bodyPr>
           <a:lstStyle/>
           <a:p>
@@ -18243,7 +18243,7 @@
         </p:spPr>
         <p:txBody>
           <a:bodyPr wrap="square" anchor="ctr">
-            <a:spAutoFit/>
+            <a:normAutofit/>
           </a:bodyPr>
           <a:lstStyle/>
           <a:p>
@@ -18324,7 +18324,7 @@
         </p:spPr>
         <p:txBody>
           <a:bodyPr wrap="square" anchor="ctr">
-            <a:spAutoFit/>
+            <a:normAutofit/>
           </a:bodyPr>
           <a:lstStyle/>
           <a:p>
@@ -18405,7 +18405,7 @@
         </p:spPr>
         <p:txBody>
           <a:bodyPr wrap="square" anchor="ctr">
-            <a:spAutoFit/>
+            <a:normAutofit/>
           </a:bodyPr>
           <a:lstStyle/>
           <a:p>
@@ -18486,7 +18486,7 @@
         </p:spPr>
         <p:txBody>
           <a:bodyPr wrap="square" anchor="ctr">
-            <a:spAutoFit/>
+            <a:normAutofit/>
           </a:bodyPr>
           <a:lstStyle/>
           <a:p>
@@ -18567,7 +18567,7 @@
         </p:spPr>
         <p:txBody>
           <a:bodyPr wrap="square" anchor="ctr">
-            <a:spAutoFit/>
+            <a:normAutofit/>
           </a:bodyPr>
           <a:lstStyle/>
           <a:p>
@@ -18648,7 +18648,7 @@
         </p:spPr>
         <p:txBody>
           <a:bodyPr wrap="square" anchor="ctr">
-            <a:spAutoFit/>
+            <a:normAutofit/>
           </a:bodyPr>
           <a:lstStyle/>
           <a:p>
@@ -18729,7 +18729,7 @@
         </p:spPr>
         <p:txBody>
           <a:bodyPr wrap="square" anchor="ctr">
-            <a:spAutoFit/>
+            <a:normAutofit/>
           </a:bodyPr>
           <a:lstStyle/>
           <a:p>
@@ -18810,7 +18810,7 @@
         </p:spPr>
         <p:txBody>
           <a:bodyPr wrap="square" anchor="ctr">
-            <a:spAutoFit/>
+            <a:normAutofit/>
           </a:bodyPr>
           <a:lstStyle/>
           <a:p>
@@ -18891,7 +18891,7 @@
         </p:spPr>
         <p:txBody>
           <a:bodyPr wrap="square" anchor="ctr">
-            <a:spAutoFit/>
+            <a:normAutofit/>
           </a:bodyPr>
           <a:lstStyle/>
           <a:p>
@@ -18972,7 +18972,7 @@
         </p:spPr>
         <p:txBody>
           <a:bodyPr wrap="square" anchor="ctr">
-            <a:spAutoFit/>
+            <a:normAutofit/>
           </a:bodyPr>
           <a:lstStyle/>
           <a:p>
@@ -19053,7 +19053,7 @@
         </p:spPr>
         <p:txBody>
           <a:bodyPr wrap="square" anchor="ctr">
-            <a:spAutoFit/>
+            <a:normAutofit/>
           </a:bodyPr>
           <a:lstStyle/>
           <a:p>
@@ -19134,7 +19134,7 @@
         </p:spPr>
         <p:txBody>
           <a:bodyPr wrap="square" anchor="ctr">
-            <a:spAutoFit/>
+            <a:normAutofit/>
           </a:bodyPr>
           <a:lstStyle/>
           <a:p>
@@ -19215,7 +19215,7 @@
         </p:spPr>
         <p:txBody>
           <a:bodyPr wrap="square" anchor="ctr">
-            <a:spAutoFit/>
+            <a:normAutofit/>
           </a:bodyPr>
           <a:lstStyle/>
           <a:p>
@@ -19296,7 +19296,7 @@
         </p:spPr>
         <p:txBody>
           <a:bodyPr wrap="square" anchor="ctr">
-            <a:spAutoFit/>
+            <a:normAutofit/>
           </a:bodyPr>
           <a:lstStyle/>
           <a:p>
@@ -19377,7 +19377,7 @@
         </p:spPr>
         <p:txBody>
           <a:bodyPr wrap="square" anchor="ctr">
-            <a:spAutoFit/>
+            <a:normAutofit/>
           </a:bodyPr>
           <a:lstStyle/>
           <a:p>
@@ -19458,7 +19458,7 @@
         </p:spPr>
         <p:txBody>
           <a:bodyPr wrap="square" anchor="ctr">
-            <a:spAutoFit/>
+            <a:normAutofit/>
           </a:bodyPr>
           <a:lstStyle/>
           <a:p>
@@ -19539,7 +19539,7 @@
         </p:spPr>
         <p:txBody>
           <a:bodyPr wrap="square" anchor="ctr">
-            <a:spAutoFit/>
+            <a:normAutofit/>
           </a:bodyPr>
           <a:lstStyle/>
           <a:p>
@@ -19636,7 +19636,7 @@
         </p:spPr>
         <p:txBody>
           <a:bodyPr wrap="square" anchor="t">
-            <a:spAutoFit/>
+            <a:normAutofit/>
           </a:bodyPr>
           <a:lstStyle/>
           <a:p>
@@ -19671,7 +19671,7 @@
         </p:spPr>
         <p:txBody>
           <a:bodyPr wrap="square" anchor="t">
-            <a:spAutoFit/>
+            <a:normAutofit/>
           </a:bodyPr>
           <a:lstStyle/>
           <a:p>
@@ -19718,7 +19718,7 @@
         </p:spPr>
         <p:txBody>
           <a:bodyPr wrap="square" anchor="t">
-            <a:spAutoFit/>
+            <a:normAutofit/>
           </a:bodyPr>
           <a:lstStyle/>
           <a:p>
@@ -19753,7 +19753,7 @@
         </p:spPr>
         <p:txBody>
           <a:bodyPr wrap="square" anchor="t">
-            <a:spAutoFit/>
+            <a:normAutofit/>
           </a:bodyPr>
           <a:lstStyle/>
           <a:p>
@@ -19832,7 +19832,7 @@
         </p:spPr>
         <p:txBody>
           <a:bodyPr wrap="square" anchor="t">
-            <a:spAutoFit/>
+            <a:normAutofit/>
           </a:bodyPr>
           <a:lstStyle/>
           <a:p>
@@ -19913,7 +19913,7 @@
         </p:spPr>
         <p:txBody>
           <a:bodyPr wrap="square" anchor="ctr">
-            <a:spAutoFit/>
+            <a:normAutofit/>
           </a:bodyPr>
           <a:lstStyle/>
           <a:p>
@@ -19994,7 +19994,7 @@
         </p:spPr>
         <p:txBody>
           <a:bodyPr wrap="square" anchor="ctr">
-            <a:spAutoFit/>
+            <a:normAutofit/>
           </a:bodyPr>
           <a:lstStyle/>
           <a:p>
@@ -20075,7 +20075,7 @@
         </p:spPr>
         <p:txBody>
           <a:bodyPr wrap="square" anchor="ctr">
-            <a:spAutoFit/>
+            <a:normAutofit/>
           </a:bodyPr>
           <a:lstStyle/>
           <a:p>
@@ -20156,7 +20156,7 @@
         </p:spPr>
         <p:txBody>
           <a:bodyPr wrap="square" anchor="ctr">
-            <a:spAutoFit/>
+            <a:normAutofit/>
           </a:bodyPr>
           <a:lstStyle/>
           <a:p>
@@ -20237,7 +20237,7 @@
         </p:spPr>
         <p:txBody>
           <a:bodyPr wrap="square" anchor="ctr">
-            <a:spAutoFit/>
+            <a:normAutofit/>
           </a:bodyPr>
           <a:lstStyle/>
           <a:p>
@@ -20318,7 +20318,7 @@
         </p:spPr>
         <p:txBody>
           <a:bodyPr wrap="square" anchor="ctr">
-            <a:spAutoFit/>
+            <a:normAutofit/>
           </a:bodyPr>
           <a:lstStyle/>
           <a:p>
@@ -20399,7 +20399,7 @@
         </p:spPr>
         <p:txBody>
           <a:bodyPr wrap="square" anchor="ctr">
-            <a:spAutoFit/>
+            <a:normAutofit/>
           </a:bodyPr>
           <a:lstStyle/>
           <a:p>
@@ -20480,7 +20480,7 @@
         </p:spPr>
         <p:txBody>
           <a:bodyPr wrap="square" anchor="ctr">
-            <a:spAutoFit/>
+            <a:normAutofit/>
           </a:bodyPr>
           <a:lstStyle/>
           <a:p>
@@ -20577,7 +20577,7 @@
         </p:spPr>
         <p:txBody>
           <a:bodyPr wrap="square" anchor="t">
-            <a:spAutoFit/>
+            <a:normAutofit/>
           </a:bodyPr>
           <a:lstStyle/>
           <a:p>
@@ -20612,7 +20612,7 @@
         </p:spPr>
         <p:txBody>
           <a:bodyPr wrap="square" anchor="t">
-            <a:spAutoFit/>
+            <a:normAutofit/>
           </a:bodyPr>
           <a:lstStyle/>
           <a:p>
@@ -20647,7 +20647,7 @@
         </p:spPr>
         <p:txBody>
           <a:bodyPr wrap="square" anchor="t">
-            <a:spAutoFit/>
+            <a:normAutofit/>
           </a:bodyPr>
           <a:lstStyle/>
           <a:p>
@@ -20682,7 +20682,7 @@
         </p:spPr>
         <p:txBody>
           <a:bodyPr wrap="square" anchor="t">
-            <a:spAutoFit/>
+            <a:normAutofit/>
           </a:bodyPr>
           <a:lstStyle/>
           <a:p>
@@ -20761,7 +20761,7 @@
         </p:spPr>
         <p:txBody>
           <a:bodyPr wrap="square" anchor="t">
-            <a:spAutoFit/>
+            <a:normAutofit/>
           </a:bodyPr>
           <a:lstStyle/>
           <a:p>
@@ -20842,7 +20842,7 @@
         </p:spPr>
         <p:txBody>
           <a:bodyPr wrap="square" anchor="t">
-            <a:spAutoFit/>
+            <a:normAutofit/>
           </a:bodyPr>
           <a:lstStyle/>
           <a:p>
@@ -20877,7 +20877,7 @@
         </p:spPr>
         <p:txBody>
           <a:bodyPr wrap="square" anchor="t">
-            <a:spAutoFit/>
+            <a:normAutofit/>
           </a:bodyPr>
           <a:lstStyle/>
           <a:p>
@@ -20958,7 +20958,7 @@
         </p:spPr>
         <p:txBody>
           <a:bodyPr wrap="square" anchor="t">
-            <a:spAutoFit/>
+            <a:normAutofit/>
           </a:bodyPr>
           <a:lstStyle/>
           <a:p>
@@ -20993,7 +20993,7 @@
         </p:spPr>
         <p:txBody>
           <a:bodyPr wrap="square" anchor="t">
-            <a:spAutoFit/>
+            <a:normAutofit/>
           </a:bodyPr>
           <a:lstStyle/>
           <a:p>
@@ -21074,7 +21074,7 @@
         </p:spPr>
         <p:txBody>
           <a:bodyPr wrap="square" anchor="t">
-            <a:spAutoFit/>
+            <a:normAutofit/>
           </a:bodyPr>
           <a:lstStyle/>
           <a:p>
@@ -21109,7 +21109,7 @@
         </p:spPr>
         <p:txBody>
           <a:bodyPr wrap="square" anchor="t">
-            <a:spAutoFit/>
+            <a:normAutofit/>
           </a:bodyPr>
           <a:lstStyle/>
           <a:p>
@@ -21190,7 +21190,7 @@
         </p:spPr>
         <p:txBody>
           <a:bodyPr wrap="square" anchor="t">
-            <a:spAutoFit/>
+            <a:normAutofit/>
           </a:bodyPr>
           <a:lstStyle/>
           <a:p>
@@ -21225,7 +21225,7 @@
         </p:spPr>
         <p:txBody>
           <a:bodyPr wrap="square" anchor="t">
-            <a:spAutoFit/>
+            <a:normAutofit/>
           </a:bodyPr>
           <a:lstStyle/>
           <a:p>
@@ -21278,7 +21278,7 @@
         </p:spPr>
         <p:txBody>
           <a:bodyPr wrap="square" anchor="t">
-            <a:spAutoFit/>
+            <a:normAutofit/>
           </a:bodyPr>
           <a:lstStyle/>
           <a:p>
@@ -21313,7 +21313,7 @@
         </p:spPr>
         <p:txBody>
           <a:bodyPr wrap="square" anchor="t">
-            <a:spAutoFit/>
+            <a:normAutofit/>
           </a:bodyPr>
           <a:lstStyle/>
           <a:p>
@@ -21348,7 +21348,7 @@
         </p:spPr>
         <p:txBody>
           <a:bodyPr wrap="square" anchor="t">
-            <a:spAutoFit/>
+            <a:normAutofit/>
           </a:bodyPr>
           <a:lstStyle/>
           <a:p>
@@ -21445,7 +21445,7 @@
         </p:spPr>
         <p:txBody>
           <a:bodyPr wrap="square" anchor="t">
-            <a:spAutoFit/>
+            <a:normAutofit/>
           </a:bodyPr>
           <a:lstStyle/>
           <a:p>
@@ -21480,7 +21480,7 @@
         </p:spPr>
         <p:txBody>
           <a:bodyPr wrap="square" anchor="t">
-            <a:spAutoFit/>
+            <a:normAutofit/>
           </a:bodyPr>
           <a:lstStyle/>
           <a:p>
@@ -21527,7 +21527,7 @@
         </p:spPr>
         <p:txBody>
           <a:bodyPr wrap="square" anchor="t">
-            <a:spAutoFit/>
+            <a:normAutofit/>
           </a:bodyPr>
           <a:lstStyle/>
           <a:p>
@@ -21562,7 +21562,7 @@
         </p:spPr>
         <p:txBody>
           <a:bodyPr wrap="square" anchor="t">
-            <a:spAutoFit/>
+            <a:normAutofit/>
           </a:bodyPr>
           <a:lstStyle/>
           <a:p>
@@ -21641,7 +21641,7 @@
         </p:spPr>
         <p:txBody>
           <a:bodyPr wrap="square" anchor="t">
-            <a:spAutoFit/>
+            <a:normAutofit/>
           </a:bodyPr>
           <a:lstStyle/>
           <a:p>
@@ -21768,7 +21768,7 @@
         </p:spPr>
         <p:txBody>
           <a:bodyPr wrap="square" anchor="t">
-            <a:spAutoFit/>
+            <a:normAutofit/>
           </a:bodyPr>
           <a:lstStyle/>
           <a:p>
@@ -21803,7 +21803,7 @@
         </p:spPr>
         <p:txBody>
           <a:bodyPr wrap="square" anchor="t">
-            <a:spAutoFit/>
+            <a:normAutofit/>
           </a:bodyPr>
           <a:lstStyle/>
           <a:p>
@@ -21838,7 +21838,7 @@
         </p:spPr>
         <p:txBody>
           <a:bodyPr wrap="square" anchor="t">
-            <a:spAutoFit/>
+            <a:normAutofit/>
           </a:bodyPr>
           <a:lstStyle/>
           <a:p>
@@ -22001,7 +22001,7 @@
         </p:spPr>
         <p:txBody>
           <a:bodyPr wrap="square" anchor="t">
-            <a:spAutoFit/>
+            <a:normAutofit/>
           </a:bodyPr>
           <a:lstStyle/>
           <a:p>
@@ -22036,7 +22036,7 @@
         </p:spPr>
         <p:txBody>
           <a:bodyPr wrap="square" anchor="t">
-            <a:spAutoFit/>
+            <a:normAutofit/>
           </a:bodyPr>
           <a:lstStyle/>
           <a:p>
@@ -22071,7 +22071,7 @@
         </p:spPr>
         <p:txBody>
           <a:bodyPr wrap="square" anchor="t">
-            <a:spAutoFit/>
+            <a:normAutofit/>
           </a:bodyPr>
           <a:lstStyle/>
           <a:p>
@@ -22234,7 +22234,7 @@
         </p:spPr>
         <p:txBody>
           <a:bodyPr wrap="square" anchor="t">
-            <a:spAutoFit/>
+            <a:normAutofit/>
           </a:bodyPr>
           <a:lstStyle/>
           <a:p>
@@ -22269,7 +22269,7 @@
         </p:spPr>
         <p:txBody>
           <a:bodyPr wrap="square" anchor="t">
-            <a:spAutoFit/>
+            <a:normAutofit/>
           </a:bodyPr>
           <a:lstStyle/>
           <a:p>
@@ -22304,7 +22304,7 @@
         </p:spPr>
         <p:txBody>
           <a:bodyPr wrap="square" anchor="t">
-            <a:spAutoFit/>
+            <a:normAutofit/>
           </a:bodyPr>
           <a:lstStyle/>
           <a:p>
@@ -22467,7 +22467,7 @@
         </p:spPr>
         <p:txBody>
           <a:bodyPr wrap="square" anchor="t">
-            <a:spAutoFit/>
+            <a:normAutofit/>
           </a:bodyPr>
           <a:lstStyle/>
           <a:p>
@@ -22502,7 +22502,7 @@
         </p:spPr>
         <p:txBody>
           <a:bodyPr wrap="square" anchor="t">
-            <a:spAutoFit/>
+            <a:normAutofit/>
           </a:bodyPr>
           <a:lstStyle/>
           <a:p>
@@ -22537,7 +22537,7 @@
         </p:spPr>
         <p:txBody>
           <a:bodyPr wrap="square" anchor="t">
-            <a:spAutoFit/>
+            <a:normAutofit/>
           </a:bodyPr>
           <a:lstStyle/>
           <a:p>
@@ -22670,7 +22670,7 @@
         </p:spPr>
         <p:txBody>
           <a:bodyPr wrap="square" anchor="t">
-            <a:spAutoFit/>
+            <a:normAutofit/>
           </a:bodyPr>
           <a:lstStyle/>
           <a:p>
@@ -22705,7 +22705,7 @@
         </p:spPr>
         <p:txBody>
           <a:bodyPr wrap="square" anchor="t">
-            <a:spAutoFit/>
+            <a:normAutofit/>
           </a:bodyPr>
           <a:lstStyle/>
           <a:p>
@@ -22752,7 +22752,7 @@
         </p:spPr>
         <p:txBody>
           <a:bodyPr wrap="square" anchor="t">
-            <a:spAutoFit/>
+            <a:normAutofit/>
           </a:bodyPr>
           <a:lstStyle/>
           <a:p>
@@ -22787,7 +22787,7 @@
         </p:spPr>
         <p:txBody>
           <a:bodyPr wrap="square" anchor="t">
-            <a:spAutoFit/>
+            <a:normAutofit/>
           </a:bodyPr>
           <a:lstStyle/>
           <a:p>
@@ -22866,7 +22866,7 @@
         </p:spPr>
         <p:txBody>
           <a:bodyPr wrap="square" anchor="t">
-            <a:spAutoFit/>
+            <a:normAutofit/>
           </a:bodyPr>
           <a:lstStyle/>
           <a:p>
@@ -22947,7 +22947,7 @@
         </p:spPr>
         <p:txBody>
           <a:bodyPr wrap="square" anchor="ctr">
-            <a:spAutoFit/>
+            <a:normAutofit/>
           </a:bodyPr>
           <a:lstStyle/>
           <a:p>
@@ -22982,7 +22982,7 @@
         </p:spPr>
         <p:txBody>
           <a:bodyPr wrap="square" anchor="ctr">
-            <a:spAutoFit/>
+            <a:normAutofit/>
           </a:bodyPr>
           <a:lstStyle/>
           <a:p>
@@ -23017,7 +23017,7 @@
         </p:spPr>
         <p:txBody>
           <a:bodyPr wrap="square" anchor="ctr">
-            <a:spAutoFit/>
+            <a:normAutofit/>
           </a:bodyPr>
           <a:lstStyle/>
           <a:p>
@@ -23098,7 +23098,7 @@
         </p:spPr>
         <p:txBody>
           <a:bodyPr wrap="square" anchor="ctr">
-            <a:spAutoFit/>
+            <a:normAutofit/>
           </a:bodyPr>
           <a:lstStyle/>
           <a:p>
@@ -23133,7 +23133,7 @@
         </p:spPr>
         <p:txBody>
           <a:bodyPr wrap="square" anchor="ctr">
-            <a:spAutoFit/>
+            <a:normAutofit/>
           </a:bodyPr>
           <a:lstStyle/>
           <a:p>
@@ -23168,7 +23168,7 @@
         </p:spPr>
         <p:txBody>
           <a:bodyPr wrap="square" anchor="ctr">
-            <a:spAutoFit/>
+            <a:normAutofit/>
           </a:bodyPr>
           <a:lstStyle/>
           <a:p>
@@ -23249,7 +23249,7 @@
         </p:spPr>
         <p:txBody>
           <a:bodyPr wrap="square" anchor="ctr">
-            <a:spAutoFit/>
+            <a:normAutofit/>
           </a:bodyPr>
           <a:lstStyle/>
           <a:p>
@@ -23284,7 +23284,7 @@
         </p:spPr>
         <p:txBody>
           <a:bodyPr wrap="square" anchor="ctr">
-            <a:spAutoFit/>
+            <a:normAutofit/>
           </a:bodyPr>
           <a:lstStyle/>
           <a:p>
@@ -23319,7 +23319,7 @@
         </p:spPr>
         <p:txBody>
           <a:bodyPr wrap="square" anchor="ctr">
-            <a:spAutoFit/>
+            <a:normAutofit/>
           </a:bodyPr>
           <a:lstStyle/>
           <a:p>
@@ -23400,7 +23400,7 @@
         </p:spPr>
         <p:txBody>
           <a:bodyPr wrap="square" anchor="ctr">
-            <a:spAutoFit/>
+            <a:normAutofit/>
           </a:bodyPr>
           <a:lstStyle/>
           <a:p>
@@ -23435,7 +23435,7 @@
         </p:spPr>
         <p:txBody>
           <a:bodyPr wrap="square" anchor="ctr">
-            <a:spAutoFit/>
+            <a:normAutofit/>
           </a:bodyPr>
           <a:lstStyle/>
           <a:p>
@@ -23470,7 +23470,7 @@
         </p:spPr>
         <p:txBody>
           <a:bodyPr wrap="square" anchor="ctr">
-            <a:spAutoFit/>
+            <a:normAutofit/>
           </a:bodyPr>
           <a:lstStyle/>
           <a:p>
@@ -23551,7 +23551,7 @@
         </p:spPr>
         <p:txBody>
           <a:bodyPr wrap="square" anchor="t">
-            <a:spAutoFit/>
+            <a:normAutofit/>
           </a:bodyPr>
           <a:lstStyle/>
           <a:p>
@@ -23586,7 +23586,7 @@
         </p:spPr>
         <p:txBody>
           <a:bodyPr wrap="square" anchor="t">
-            <a:spAutoFit/>
+            <a:normAutofit/>
           </a:bodyPr>
           <a:lstStyle/>
           <a:p>
@@ -23767,7 +23767,7 @@
         </p:spPr>
         <p:txBody>
           <a:bodyPr wrap="square" anchor="t">
-            <a:spAutoFit/>
+            <a:normAutofit/>
           </a:bodyPr>
           <a:lstStyle/>
           <a:p>
@@ -23802,7 +23802,7 @@
         </p:spPr>
         <p:txBody>
           <a:bodyPr wrap="square" anchor="t">
-            <a:spAutoFit/>
+            <a:normAutofit/>
           </a:bodyPr>
           <a:lstStyle/>
           <a:p>
@@ -23981,7 +23981,7 @@
         </p:spPr>
         <p:txBody>
           <a:bodyPr wrap="square" anchor="t">
-            <a:spAutoFit/>
+            <a:normAutofit/>
           </a:bodyPr>
           <a:lstStyle/>
           <a:p>
@@ -24016,7 +24016,7 @@
         </p:spPr>
         <p:txBody>
           <a:bodyPr wrap="square" anchor="t">
-            <a:spAutoFit/>
+            <a:normAutofit/>
           </a:bodyPr>
           <a:lstStyle/>
           <a:p>
@@ -24051,7 +24051,7 @@
         </p:spPr>
         <p:txBody>
           <a:bodyPr wrap="square" anchor="t">
-            <a:spAutoFit/>
+            <a:normAutofit/>
           </a:bodyPr>
           <a:lstStyle/>
           <a:p>
@@ -24086,7 +24086,7 @@
         </p:spPr>
         <p:txBody>
           <a:bodyPr wrap="square" anchor="t">
-            <a:spAutoFit/>
+            <a:normAutofit/>
           </a:bodyPr>
           <a:lstStyle/>
           <a:p>
@@ -24167,7 +24167,7 @@
         </p:spPr>
         <p:txBody>
           <a:bodyPr wrap="square" anchor="t">
-            <a:spAutoFit/>
+            <a:normAutofit/>
           </a:bodyPr>
           <a:lstStyle/>
           <a:p>
@@ -24202,7 +24202,7 @@
         </p:spPr>
         <p:txBody>
           <a:bodyPr wrap="square" anchor="ctr">
-            <a:spAutoFit/>
+            <a:normAutofit/>
           </a:bodyPr>
           <a:lstStyle/>
           <a:p>
@@ -24237,7 +24237,7 @@
         </p:spPr>
         <p:txBody>
           <a:bodyPr wrap="square" anchor="ctr">
-            <a:spAutoFit/>
+            <a:normAutofit/>
           </a:bodyPr>
           <a:lstStyle/>
           <a:p>
@@ -24318,7 +24318,7 @@
         </p:spPr>
         <p:txBody>
           <a:bodyPr wrap="square" anchor="t">
-            <a:spAutoFit/>
+            <a:normAutofit/>
           </a:bodyPr>
           <a:lstStyle/>
           <a:p>
@@ -24353,7 +24353,7 @@
         </p:spPr>
         <p:txBody>
           <a:bodyPr wrap="square" anchor="ctr">
-            <a:spAutoFit/>
+            <a:normAutofit/>
           </a:bodyPr>
           <a:lstStyle/>
           <a:p>
@@ -24388,7 +24388,7 @@
         </p:spPr>
         <p:txBody>
           <a:bodyPr wrap="square" anchor="ctr">
-            <a:spAutoFit/>
+            <a:normAutofit/>
           </a:bodyPr>
           <a:lstStyle/>
           <a:p>
@@ -24469,7 +24469,7 @@
         </p:spPr>
         <p:txBody>
           <a:bodyPr wrap="square" anchor="t">
-            <a:spAutoFit/>
+            <a:normAutofit/>
           </a:bodyPr>
           <a:lstStyle/>
           <a:p>
@@ -24504,7 +24504,7 @@
         </p:spPr>
         <p:txBody>
           <a:bodyPr wrap="square" anchor="ctr">
-            <a:spAutoFit/>
+            <a:normAutofit/>
           </a:bodyPr>
           <a:lstStyle/>
           <a:p>
@@ -24539,7 +24539,7 @@
         </p:spPr>
         <p:txBody>
           <a:bodyPr wrap="square" anchor="ctr">
-            <a:spAutoFit/>
+            <a:normAutofit/>
           </a:bodyPr>
           <a:lstStyle/>
           <a:p>
@@ -24620,7 +24620,7 @@
         </p:spPr>
         <p:txBody>
           <a:bodyPr wrap="square" anchor="t">
-            <a:spAutoFit/>
+            <a:normAutofit/>
           </a:bodyPr>
           <a:lstStyle/>
           <a:p>
@@ -24655,7 +24655,7 @@
         </p:spPr>
         <p:txBody>
           <a:bodyPr wrap="square" anchor="ctr">
-            <a:spAutoFit/>
+            <a:normAutofit/>
           </a:bodyPr>
           <a:lstStyle/>
           <a:p>
@@ -24690,7 +24690,7 @@
         </p:spPr>
         <p:txBody>
           <a:bodyPr wrap="square" anchor="ctr">
-            <a:spAutoFit/>
+            <a:normAutofit/>
           </a:bodyPr>
           <a:lstStyle/>
           <a:p>
@@ -24771,7 +24771,7 @@
         </p:spPr>
         <p:txBody>
           <a:bodyPr wrap="square" anchor="t">
-            <a:spAutoFit/>
+            <a:normAutofit/>
           </a:bodyPr>
           <a:lstStyle/>
           <a:p>
@@ -24806,7 +24806,7 @@
         </p:spPr>
         <p:txBody>
           <a:bodyPr wrap="square" anchor="ctr">
-            <a:spAutoFit/>
+            <a:normAutofit/>
           </a:bodyPr>
           <a:lstStyle/>
           <a:p>
@@ -24841,7 +24841,7 @@
         </p:spPr>
         <p:txBody>
           <a:bodyPr wrap="square" anchor="ctr">
-            <a:spAutoFit/>
+            <a:normAutofit/>
           </a:bodyPr>
           <a:lstStyle/>
           <a:p>
@@ -24922,7 +24922,7 @@
         </p:spPr>
         <p:txBody>
           <a:bodyPr wrap="square" anchor="t">
-            <a:spAutoFit/>
+            <a:normAutofit/>
           </a:bodyPr>
           <a:lstStyle/>
           <a:p>
@@ -25019,7 +25019,7 @@
         </p:spPr>
         <p:txBody>
           <a:bodyPr wrap="square" anchor="t">
-            <a:spAutoFit/>
+            <a:normAutofit/>
           </a:bodyPr>
           <a:lstStyle/>
           <a:p>
@@ -25054,7 +25054,7 @@
         </p:spPr>
         <p:txBody>
           <a:bodyPr wrap="square" anchor="t">
-            <a:spAutoFit/>
+            <a:normAutofit/>
           </a:bodyPr>
           <a:lstStyle/>
           <a:p>
@@ -25089,7 +25089,7 @@
         </p:spPr>
         <p:txBody>
           <a:bodyPr wrap="square" anchor="t">
-            <a:spAutoFit/>
+            <a:normAutofit/>
           </a:bodyPr>
           <a:lstStyle/>
           <a:p>
@@ -25124,7 +25124,7 @@
         </p:spPr>
         <p:txBody>
           <a:bodyPr wrap="square" anchor="t">
-            <a:spAutoFit/>
+            <a:normAutofit/>
           </a:bodyPr>
           <a:lstStyle/>
           <a:p>
@@ -25203,7 +25203,7 @@
         </p:spPr>
         <p:txBody>
           <a:bodyPr wrap="square" anchor="t">
-            <a:spAutoFit/>
+            <a:normAutofit/>
           </a:bodyPr>
           <a:lstStyle/>
           <a:p>
@@ -25284,7 +25284,7 @@
         </p:spPr>
         <p:txBody>
           <a:bodyPr wrap="square" anchor="t">
-            <a:spAutoFit/>
+            <a:normAutofit/>
           </a:bodyPr>
           <a:lstStyle/>
           <a:p>
@@ -25319,7 +25319,7 @@
         </p:spPr>
         <p:txBody>
           <a:bodyPr wrap="square" anchor="t">
-            <a:spAutoFit/>
+            <a:normAutofit/>
           </a:bodyPr>
           <a:lstStyle/>
           <a:p>
@@ -25354,7 +25354,7 @@
         </p:spPr>
         <p:txBody>
           <a:bodyPr wrap="square" anchor="t">
-            <a:spAutoFit/>
+            <a:normAutofit/>
           </a:bodyPr>
           <a:lstStyle/>
           <a:p>
@@ -25447,7 +25447,7 @@
         </p:spPr>
         <p:txBody>
           <a:bodyPr wrap="square" anchor="t">
-            <a:spAutoFit/>
+            <a:normAutofit/>
           </a:bodyPr>
           <a:lstStyle/>
           <a:p>
@@ -25482,7 +25482,7 @@
         </p:spPr>
         <p:txBody>
           <a:bodyPr wrap="square" anchor="t">
-            <a:spAutoFit/>
+            <a:normAutofit/>
           </a:bodyPr>
           <a:lstStyle/>
           <a:p>
@@ -25529,7 +25529,7 @@
         </p:spPr>
         <p:txBody>
           <a:bodyPr wrap="square" anchor="t">
-            <a:spAutoFit/>
+            <a:normAutofit/>
           </a:bodyPr>
           <a:lstStyle/>
           <a:p>
@@ -25622,7 +25622,7 @@
         </p:spPr>
         <p:txBody>
           <a:bodyPr wrap="square" anchor="t">
-            <a:spAutoFit/>
+            <a:normAutofit/>
           </a:bodyPr>
           <a:lstStyle/>
           <a:p>
@@ -25657,7 +25657,7 @@
         </p:spPr>
         <p:txBody>
           <a:bodyPr wrap="square" anchor="t">
-            <a:spAutoFit/>
+            <a:normAutofit/>
           </a:bodyPr>
           <a:lstStyle/>
           <a:p>
@@ -25692,7 +25692,7 @@
         </p:spPr>
         <p:txBody>
           <a:bodyPr wrap="square" anchor="t">
-            <a:spAutoFit/>
+            <a:normAutofit/>
           </a:bodyPr>
           <a:lstStyle/>
           <a:p>
@@ -25785,7 +25785,7 @@
         </p:spPr>
         <p:txBody>
           <a:bodyPr wrap="square" anchor="t">
-            <a:spAutoFit/>
+            <a:normAutofit/>
           </a:bodyPr>
           <a:lstStyle/>
           <a:p>
@@ -25820,7 +25820,7 @@
         </p:spPr>
         <p:txBody>
           <a:bodyPr wrap="square" anchor="t">
-            <a:spAutoFit/>
+            <a:normAutofit/>
           </a:bodyPr>
           <a:lstStyle/>
           <a:p>
@@ -25867,7 +25867,7 @@
         </p:spPr>
         <p:txBody>
           <a:bodyPr wrap="square" anchor="t">
-            <a:spAutoFit/>
+            <a:normAutofit/>
           </a:bodyPr>
           <a:lstStyle/>
           <a:p>
@@ -25960,7 +25960,7 @@
         </p:spPr>
         <p:txBody>
           <a:bodyPr wrap="square" anchor="t">
-            <a:spAutoFit/>
+            <a:normAutofit/>
           </a:bodyPr>
           <a:lstStyle/>
           <a:p>
@@ -25995,7 +25995,7 @@
         </p:spPr>
         <p:txBody>
           <a:bodyPr wrap="square" anchor="t">
-            <a:spAutoFit/>
+            <a:normAutofit/>
           </a:bodyPr>
           <a:lstStyle/>
           <a:p>
@@ -26042,7 +26042,7 @@
         </p:spPr>
         <p:txBody>
           <a:bodyPr wrap="square" anchor="t">
-            <a:spAutoFit/>
+            <a:normAutofit/>
           </a:bodyPr>
           <a:lstStyle/>
           <a:p>
@@ -26135,7 +26135,7 @@
         </p:spPr>
         <p:txBody>
           <a:bodyPr wrap="square" anchor="t">
-            <a:spAutoFit/>
+            <a:normAutofit/>
           </a:bodyPr>
           <a:lstStyle/>
           <a:p>
@@ -26170,7 +26170,7 @@
         </p:spPr>
         <p:txBody>
           <a:bodyPr wrap="square" anchor="t">
-            <a:spAutoFit/>
+            <a:normAutofit/>
           </a:bodyPr>
           <a:lstStyle/>
           <a:p>
@@ -26217,7 +26217,7 @@
         </p:spPr>
         <p:txBody>
           <a:bodyPr wrap="square" anchor="t">
-            <a:spAutoFit/>
+            <a:normAutofit/>
           </a:bodyPr>
           <a:lstStyle/>
           <a:p>
@@ -26326,7 +26326,7 @@
         </p:spPr>
         <p:txBody>
           <a:bodyPr wrap="square" anchor="t">
-            <a:spAutoFit/>
+            <a:normAutofit/>
           </a:bodyPr>
           <a:lstStyle/>
           <a:p>
@@ -26361,7 +26361,7 @@
         </p:spPr>
         <p:txBody>
           <a:bodyPr wrap="square" anchor="t">
-            <a:spAutoFit/>
+            <a:normAutofit/>
           </a:bodyPr>
           <a:lstStyle/>
           <a:p>
@@ -26408,7 +26408,7 @@
         </p:spPr>
         <p:txBody>
           <a:bodyPr wrap="square" anchor="t">
-            <a:spAutoFit/>
+            <a:normAutofit/>
           </a:bodyPr>
           <a:lstStyle/>
           <a:p>
@@ -26443,7 +26443,7 @@
         </p:spPr>
         <p:txBody>
           <a:bodyPr wrap="square" anchor="t">
-            <a:spAutoFit/>
+            <a:normAutofit/>
           </a:bodyPr>
           <a:lstStyle/>
           <a:p>
@@ -26522,7 +26522,7 @@
         </p:spPr>
         <p:txBody>
           <a:bodyPr wrap="square" anchor="t">
-            <a:spAutoFit/>
+            <a:normAutofit/>
           </a:bodyPr>
           <a:lstStyle/>
           <a:p>
@@ -26603,7 +26603,7 @@
         </p:spPr>
         <p:txBody>
           <a:bodyPr wrap="square" anchor="ctr">
-            <a:spAutoFit/>
+            <a:normAutofit/>
           </a:bodyPr>
           <a:lstStyle/>
           <a:p>
@@ -26638,7 +26638,7 @@
         </p:spPr>
         <p:txBody>
           <a:bodyPr wrap="square" anchor="ctr">
-            <a:spAutoFit/>
+            <a:normAutofit/>
           </a:bodyPr>
           <a:lstStyle/>
           <a:p>
@@ -26719,7 +26719,7 @@
         </p:spPr>
         <p:txBody>
           <a:bodyPr wrap="square" anchor="ctr">
-            <a:spAutoFit/>
+            <a:normAutofit/>
           </a:bodyPr>
           <a:lstStyle/>
           <a:p>
@@ -26754,7 +26754,7 @@
         </p:spPr>
         <p:txBody>
           <a:bodyPr wrap="square" anchor="ctr">
-            <a:spAutoFit/>
+            <a:normAutofit/>
           </a:bodyPr>
           <a:lstStyle/>
           <a:p>
@@ -26835,7 +26835,7 @@
         </p:spPr>
         <p:txBody>
           <a:bodyPr wrap="square" anchor="ctr">
-            <a:spAutoFit/>
+            <a:normAutofit/>
           </a:bodyPr>
           <a:lstStyle/>
           <a:p>
@@ -26870,7 +26870,7 @@
         </p:spPr>
         <p:txBody>
           <a:bodyPr wrap="square" anchor="ctr">
-            <a:spAutoFit/>
+            <a:normAutofit/>
           </a:bodyPr>
           <a:lstStyle/>
           <a:p>
@@ -26951,7 +26951,7 @@
         </p:spPr>
         <p:txBody>
           <a:bodyPr wrap="square" anchor="ctr">
-            <a:spAutoFit/>
+            <a:normAutofit/>
           </a:bodyPr>
           <a:lstStyle/>
           <a:p>
@@ -26986,7 +26986,7 @@
         </p:spPr>
         <p:txBody>
           <a:bodyPr wrap="square" anchor="ctr">
-            <a:spAutoFit/>
+            <a:normAutofit/>
           </a:bodyPr>
           <a:lstStyle/>
           <a:p>
@@ -27067,7 +27067,7 @@
         </p:spPr>
         <p:txBody>
           <a:bodyPr wrap="square" anchor="t">
-            <a:spAutoFit/>
+            <a:normAutofit/>
           </a:bodyPr>
           <a:lstStyle/>
           <a:p>
@@ -27102,7 +27102,7 @@
         </p:spPr>
         <p:txBody>
           <a:bodyPr wrap="square" anchor="t">
-            <a:spAutoFit/>
+            <a:normAutofit/>
           </a:bodyPr>
           <a:lstStyle/>
           <a:p>
@@ -27331,7 +27331,7 @@
         </p:spPr>
         <p:txBody>
           <a:bodyPr wrap="square" anchor="t">
-            <a:spAutoFit/>
+            <a:normAutofit/>
           </a:bodyPr>
           <a:lstStyle/>
           <a:p>
@@ -27366,7 +27366,7 @@
         </p:spPr>
         <p:txBody>
           <a:bodyPr wrap="square" anchor="t">
-            <a:spAutoFit/>
+            <a:normAutofit/>
           </a:bodyPr>
           <a:lstStyle/>
           <a:p>
@@ -27413,7 +27413,7 @@
         </p:spPr>
         <p:txBody>
           <a:bodyPr wrap="square" anchor="t">
-            <a:spAutoFit/>
+            <a:normAutofit/>
           </a:bodyPr>
           <a:lstStyle/>
           <a:p>
@@ -27448,7 +27448,7 @@
         </p:spPr>
         <p:txBody>
           <a:bodyPr wrap="square" anchor="t">
-            <a:spAutoFit/>
+            <a:normAutofit/>
           </a:bodyPr>
           <a:lstStyle/>
           <a:p>
@@ -27527,7 +27527,7 @@
         </p:spPr>
         <p:txBody>
           <a:bodyPr wrap="square" anchor="t">
-            <a:spAutoFit/>
+            <a:normAutofit/>
           </a:bodyPr>
           <a:lstStyle/>
           <a:p>
@@ -27654,7 +27654,7 @@
         </p:spPr>
         <p:txBody>
           <a:bodyPr wrap="square" anchor="t">
-            <a:spAutoFit/>
+            <a:normAutofit/>
           </a:bodyPr>
           <a:lstStyle/>
           <a:p>
@@ -27689,7 +27689,7 @@
         </p:spPr>
         <p:txBody>
           <a:bodyPr wrap="square" anchor="t">
-            <a:spAutoFit/>
+            <a:normAutofit/>
           </a:bodyPr>
           <a:lstStyle/>
           <a:p>
@@ -27724,7 +27724,7 @@
         </p:spPr>
         <p:txBody>
           <a:bodyPr wrap="square" anchor="t">
-            <a:spAutoFit/>
+            <a:normAutofit/>
           </a:bodyPr>
           <a:lstStyle/>
           <a:p>
@@ -27759,7 +27759,7 @@
         </p:spPr>
         <p:txBody>
           <a:bodyPr wrap="square" anchor="t">
-            <a:spAutoFit/>
+            <a:normAutofit/>
           </a:bodyPr>
           <a:lstStyle/>
           <a:p>
@@ -27886,7 +27886,7 @@
         </p:spPr>
         <p:txBody>
           <a:bodyPr wrap="square" anchor="t">
-            <a:spAutoFit/>
+            <a:normAutofit/>
           </a:bodyPr>
           <a:lstStyle/>
           <a:p>
@@ -27921,7 +27921,7 @@
         </p:spPr>
         <p:txBody>
           <a:bodyPr wrap="square" anchor="t">
-            <a:spAutoFit/>
+            <a:normAutofit/>
           </a:bodyPr>
           <a:lstStyle/>
           <a:p>
@@ -27956,7 +27956,7 @@
         </p:spPr>
         <p:txBody>
           <a:bodyPr wrap="square" anchor="t">
-            <a:spAutoFit/>
+            <a:normAutofit/>
           </a:bodyPr>
           <a:lstStyle/>
           <a:p>
@@ -27991,7 +27991,7 @@
         </p:spPr>
         <p:txBody>
           <a:bodyPr wrap="square" anchor="t">
-            <a:spAutoFit/>
+            <a:normAutofit/>
           </a:bodyPr>
           <a:lstStyle/>
           <a:p>
@@ -28118,7 +28118,7 @@
         </p:spPr>
         <p:txBody>
           <a:bodyPr wrap="square" anchor="t">
-            <a:spAutoFit/>
+            <a:normAutofit/>
           </a:bodyPr>
           <a:lstStyle/>
           <a:p>
@@ -28153,7 +28153,7 @@
         </p:spPr>
         <p:txBody>
           <a:bodyPr wrap="square" anchor="t">
-            <a:spAutoFit/>
+            <a:normAutofit/>
           </a:bodyPr>
           <a:lstStyle/>
           <a:p>
@@ -28188,7 +28188,7 @@
         </p:spPr>
         <p:txBody>
           <a:bodyPr wrap="square" anchor="t">
-            <a:spAutoFit/>
+            <a:normAutofit/>
           </a:bodyPr>
           <a:lstStyle/>
           <a:p>
@@ -28223,7 +28223,7 @@
         </p:spPr>
         <p:txBody>
           <a:bodyPr wrap="square" anchor="t">
-            <a:spAutoFit/>
+            <a:normAutofit/>
           </a:bodyPr>
           <a:lstStyle/>
           <a:p>
@@ -28258,7 +28258,7 @@
         </p:spPr>
         <p:txBody>
           <a:bodyPr wrap="square" anchor="t">
-            <a:spAutoFit/>
+            <a:normAutofit/>
           </a:bodyPr>
           <a:lstStyle/>
           <a:p>
@@ -28401,7 +28401,7 @@
         </p:spPr>
         <p:txBody>
           <a:bodyPr wrap="square" anchor="t">
-            <a:spAutoFit/>
+            <a:normAutofit/>
           </a:bodyPr>
           <a:lstStyle/>
           <a:p>
@@ -28436,7 +28436,7 @@
         </p:spPr>
         <p:txBody>
           <a:bodyPr wrap="square" anchor="t">
-            <a:spAutoFit/>
+            <a:normAutofit/>
           </a:bodyPr>
           <a:lstStyle/>
           <a:p>
@@ -28483,7 +28483,7 @@
         </p:spPr>
         <p:txBody>
           <a:bodyPr wrap="square" anchor="t">
-            <a:spAutoFit/>
+            <a:normAutofit/>
           </a:bodyPr>
           <a:lstStyle/>
           <a:p>
@@ -28562,7 +28562,7 @@
         </p:spPr>
         <p:txBody>
           <a:bodyPr wrap="square" anchor="t">
-            <a:spAutoFit/>
+            <a:normAutofit/>
           </a:bodyPr>
           <a:lstStyle/>
           <a:p>
@@ -28659,7 +28659,7 @@
         </p:spPr>
         <p:txBody>
           <a:bodyPr wrap="square" anchor="t">
-            <a:spAutoFit/>
+            <a:normAutofit/>
           </a:bodyPr>
           <a:lstStyle/>
           <a:p>
@@ -28694,7 +28694,7 @@
         </p:spPr>
         <p:txBody>
           <a:bodyPr wrap="square" anchor="t">
-            <a:spAutoFit/>
+            <a:normAutofit/>
           </a:bodyPr>
           <a:lstStyle/>
           <a:p>
@@ -28729,7 +28729,7 @@
         </p:spPr>
         <p:txBody>
           <a:bodyPr wrap="square" anchor="t">
-            <a:spAutoFit/>
+            <a:normAutofit/>
           </a:bodyPr>
           <a:lstStyle/>
           <a:p>
@@ -28764,7 +28764,7 @@
         </p:spPr>
         <p:txBody>
           <a:bodyPr wrap="square" anchor="t">
-            <a:spAutoFit/>
+            <a:normAutofit/>
           </a:bodyPr>
           <a:lstStyle/>
           <a:p>
@@ -28843,7 +28843,7 @@
         </p:spPr>
         <p:txBody>
           <a:bodyPr wrap="square" anchor="t">
-            <a:spAutoFit/>
+            <a:normAutofit/>
           </a:bodyPr>
           <a:lstStyle/>
           <a:p>
@@ -28970,7 +28970,7 @@
         </p:spPr>
         <p:txBody>
           <a:bodyPr wrap="square" anchor="ctr">
-            <a:spAutoFit/>
+            <a:normAutofit/>
           </a:bodyPr>
           <a:lstStyle/>
           <a:p>
@@ -29017,7 +29017,7 @@
         </p:spPr>
         <p:txBody>
           <a:bodyPr wrap="square" anchor="t">
-            <a:spAutoFit/>
+            <a:normAutofit/>
           </a:bodyPr>
           <a:lstStyle/>
           <a:p>
@@ -29212,7 +29212,7 @@
         </p:spPr>
         <p:txBody>
           <a:bodyPr wrap="square" anchor="ctr">
-            <a:spAutoFit/>
+            <a:normAutofit/>
           </a:bodyPr>
           <a:lstStyle/>
           <a:p>
@@ -29259,7 +29259,7 @@
         </p:spPr>
         <p:txBody>
           <a:bodyPr wrap="square" anchor="t">
-            <a:spAutoFit/>
+            <a:normAutofit/>
           </a:bodyPr>
           <a:lstStyle/>
           <a:p>
@@ -29454,7 +29454,7 @@
         </p:spPr>
         <p:txBody>
           <a:bodyPr wrap="square" anchor="ctr">
-            <a:spAutoFit/>
+            <a:normAutofit/>
           </a:bodyPr>
           <a:lstStyle/>
           <a:p>
@@ -29501,7 +29501,7 @@
         </p:spPr>
         <p:txBody>
           <a:bodyPr wrap="square" anchor="t">
-            <a:spAutoFit/>
+            <a:normAutofit/>
           </a:bodyPr>
           <a:lstStyle/>
           <a:p>
@@ -29604,7 +29604,7 @@
         </p:spPr>
         <p:txBody>
           <a:bodyPr wrap="square" anchor="t">
-            <a:spAutoFit/>
+            <a:normAutofit/>
           </a:bodyPr>
           <a:lstStyle/>
           <a:p>
@@ -29701,7 +29701,7 @@
         </p:spPr>
         <p:txBody>
           <a:bodyPr wrap="square" anchor="t">
-            <a:spAutoFit/>
+            <a:normAutofit/>
           </a:bodyPr>
           <a:lstStyle/>
           <a:p>
@@ -29736,7 +29736,7 @@
         </p:spPr>
         <p:txBody>
           <a:bodyPr wrap="square" anchor="t">
-            <a:spAutoFit/>
+            <a:normAutofit/>
           </a:bodyPr>
           <a:lstStyle/>
           <a:p>
@@ -29783,7 +29783,7 @@
         </p:spPr>
         <p:txBody>
           <a:bodyPr wrap="square" anchor="t">
-            <a:spAutoFit/>
+            <a:normAutofit/>
           </a:bodyPr>
           <a:lstStyle/>
           <a:p>
@@ -29818,7 +29818,7 @@
         </p:spPr>
         <p:txBody>
           <a:bodyPr wrap="square" anchor="t">
-            <a:spAutoFit/>
+            <a:normAutofit/>
           </a:bodyPr>
           <a:lstStyle/>
           <a:p>
@@ -29897,7 +29897,7 @@
         </p:spPr>
         <p:txBody>
           <a:bodyPr wrap="square" anchor="t">
-            <a:spAutoFit/>
+            <a:normAutofit/>
           </a:bodyPr>
           <a:lstStyle/>
           <a:p>
@@ -29978,7 +29978,7 @@
         </p:spPr>
         <p:txBody>
           <a:bodyPr wrap="square" anchor="t">
-            <a:spAutoFit/>
+            <a:normAutofit/>
           </a:bodyPr>
           <a:lstStyle/>
           <a:p>
@@ -30013,7 +30013,7 @@
         </p:spPr>
         <p:txBody>
           <a:bodyPr wrap="square" anchor="t">
-            <a:spAutoFit/>
+            <a:normAutofit/>
           </a:bodyPr>
           <a:lstStyle/>
           <a:p>
@@ -30048,7 +30048,7 @@
         </p:spPr>
         <p:txBody>
           <a:bodyPr wrap="square" anchor="t">
-            <a:spAutoFit/>
+            <a:normAutofit/>
           </a:bodyPr>
           <a:lstStyle/>
           <a:p>
@@ -30083,7 +30083,7 @@
         </p:spPr>
         <p:txBody>
           <a:bodyPr wrap="square" anchor="t">
-            <a:spAutoFit/>
+            <a:normAutofit/>
           </a:bodyPr>
           <a:lstStyle/>
           <a:p>
@@ -30118,7 +30118,7 @@
         </p:spPr>
         <p:txBody>
           <a:bodyPr wrap="square" anchor="t">
-            <a:spAutoFit/>
+            <a:normAutofit/>
           </a:bodyPr>
           <a:lstStyle/>
           <a:p>
@@ -30153,7 +30153,7 @@
         </p:spPr>
         <p:txBody>
           <a:bodyPr wrap="square" anchor="t">
-            <a:spAutoFit/>
+            <a:normAutofit/>
           </a:bodyPr>
           <a:lstStyle/>
           <a:p>
@@ -30188,7 +30188,7 @@
         </p:spPr>
         <p:txBody>
           <a:bodyPr wrap="square" anchor="t">
-            <a:spAutoFit/>
+            <a:normAutofit/>
           </a:bodyPr>
           <a:lstStyle/>
           <a:p>
@@ -30223,7 +30223,7 @@
         </p:spPr>
         <p:txBody>
           <a:bodyPr wrap="square" anchor="t">
-            <a:spAutoFit/>
+            <a:normAutofit/>
           </a:bodyPr>
           <a:lstStyle/>
           <a:p>
@@ -30258,7 +30258,7 @@
         </p:spPr>
         <p:txBody>
           <a:bodyPr wrap="square" anchor="t">
-            <a:spAutoFit/>
+            <a:normAutofit/>
           </a:bodyPr>
           <a:lstStyle/>
           <a:p>
@@ -30339,7 +30339,7 @@
         </p:spPr>
         <p:txBody>
           <a:bodyPr wrap="square" anchor="t">
-            <a:spAutoFit/>
+            <a:normAutofit/>
           </a:bodyPr>
           <a:lstStyle/>
           <a:p>
@@ -30420,7 +30420,7 @@
         </p:spPr>
         <p:txBody>
           <a:bodyPr wrap="square" anchor="t">
-            <a:spAutoFit/>
+            <a:normAutofit/>
           </a:bodyPr>
           <a:lstStyle/>
           <a:p>
@@ -30501,7 +30501,7 @@
         </p:spPr>
         <p:txBody>
           <a:bodyPr wrap="square" anchor="t">
-            <a:spAutoFit/>
+            <a:normAutofit/>
           </a:bodyPr>
           <a:lstStyle/>
           <a:p>
@@ -30582,7 +30582,7 @@
         </p:spPr>
         <p:txBody>
           <a:bodyPr wrap="square" anchor="t">
-            <a:spAutoFit/>
+            <a:normAutofit/>
           </a:bodyPr>
           <a:lstStyle/>
           <a:p>
@@ -30663,7 +30663,7 @@
         </p:spPr>
         <p:txBody>
           <a:bodyPr wrap="square" anchor="t">
-            <a:spAutoFit/>
+            <a:normAutofit/>
           </a:bodyPr>
           <a:lstStyle/>
           <a:p>
@@ -30744,7 +30744,7 @@
         </p:spPr>
         <p:txBody>
           <a:bodyPr wrap="square" anchor="t">
-            <a:spAutoFit/>
+            <a:normAutofit/>
           </a:bodyPr>
           <a:lstStyle/>
           <a:p>
@@ -30865,7 +30865,7 @@
         </p:spPr>
         <p:txBody>
           <a:bodyPr wrap="square" anchor="t">
-            <a:spAutoFit/>
+            <a:normAutofit/>
           </a:bodyPr>
           <a:lstStyle/>
           <a:p>
@@ -30900,7 +30900,7 @@
         </p:spPr>
         <p:txBody>
           <a:bodyPr wrap="square" anchor="t">
-            <a:spAutoFit/>
+            <a:normAutofit/>
           </a:bodyPr>
           <a:lstStyle/>
           <a:p>
@@ -30947,7 +30947,7 @@
         </p:spPr>
         <p:txBody>
           <a:bodyPr wrap="square" anchor="t">
-            <a:spAutoFit/>
+            <a:normAutofit/>
           </a:bodyPr>
           <a:lstStyle/>
           <a:p>
@@ -30982,7 +30982,7 @@
         </p:spPr>
         <p:txBody>
           <a:bodyPr wrap="square" anchor="t">
-            <a:spAutoFit/>
+            <a:normAutofit/>
           </a:bodyPr>
           <a:lstStyle/>
           <a:p>
@@ -31061,7 +31061,7 @@
         </p:spPr>
         <p:txBody>
           <a:bodyPr wrap="square" anchor="t">
-            <a:spAutoFit/>
+            <a:normAutofit/>
           </a:bodyPr>
           <a:lstStyle/>
           <a:p>
@@ -31096,7 +31096,7 @@
         </p:spPr>
         <p:txBody>
           <a:bodyPr wrap="square" anchor="t">
-            <a:spAutoFit/>
+            <a:normAutofit/>
           </a:bodyPr>
           <a:lstStyle/>
           <a:p>
@@ -31223,7 +31223,7 @@
         </p:spPr>
         <p:txBody>
           <a:bodyPr wrap="square" anchor="t">
-            <a:spAutoFit/>
+            <a:normAutofit/>
           </a:bodyPr>
           <a:lstStyle/>
           <a:p>
@@ -31258,7 +31258,7 @@
         </p:spPr>
         <p:txBody>
           <a:bodyPr wrap="square" anchor="t">
-            <a:spAutoFit/>
+            <a:normAutofit/>
           </a:bodyPr>
           <a:lstStyle/>
           <a:p>
@@ -31485,7 +31485,7 @@
         </p:spPr>
         <p:txBody>
           <a:bodyPr wrap="square" anchor="t">
-            <a:spAutoFit/>
+            <a:normAutofit/>
           </a:bodyPr>
           <a:lstStyle/>
           <a:p>
@@ -31520,7 +31520,7 @@
         </p:spPr>
         <p:txBody>
           <a:bodyPr wrap="square" anchor="t">
-            <a:spAutoFit/>
+            <a:normAutofit/>
           </a:bodyPr>
           <a:lstStyle/>
           <a:p>
@@ -31701,7 +31701,7 @@
         </p:spPr>
         <p:txBody>
           <a:bodyPr wrap="square" anchor="t">
-            <a:spAutoFit/>
+            <a:normAutofit/>
           </a:bodyPr>
           <a:lstStyle/>
           <a:p>

</xml_diff>

<commit_message>
Corum pitch: slide 2 herbouwd in authentieke CBOE-stijl (amber label+descriptor, amber sub-koppen met streepje, amber serif pull-quote als Question, navy answer-card)
Co-Authored-By: Claude Opus 4.8 <noreply@anthropic.com>
Claude-Session: https://claude.ai/code/session_01Ve1ndCHgviaGx4xoosLGch
</commit_message>
<xml_diff>
--- a/corum-pitch/Corum-Westgate-I-Pitch-STYLED.pptx
+++ b/corum-pitch/Corum-Westgate-I-Pitch-STYLED.pptx
@@ -19576,45 +19576,36 @@
       <p:grpSpPr/>
       <p:sp>
         <p:nvSpPr>
-          <p:cNvPr id="2" name="Rectangle 1"/>
-          <p:cNvSpPr/>
-          <p:nvPr/>
-        </p:nvSpPr>
-        <p:spPr>
-          <a:xfrm>
-            <a:off x="0" y="0"/>
-            <a:ext cx="128016" cy="6858000"/>
-          </a:xfrm>
-          <a:prstGeom prst="rect">
-            <a:avLst/>
-          </a:prstGeom>
-          <a:solidFill>
-            <a:srgbClr val="F4B634"/>
-          </a:solidFill>
-          <a:ln>
-            <a:noFill/>
-          </a:ln>
-          <a:effectLst/>
-        </p:spPr>
-        <p:style>
-          <a:lnRef idx="1">
-            <a:schemeClr val="accent1"/>
-          </a:lnRef>
-          <a:fillRef idx="3">
-            <a:schemeClr val="accent1"/>
-          </a:fillRef>
-          <a:effectRef idx="2">
-            <a:schemeClr val="accent1"/>
-          </a:effectRef>
-          <a:fontRef idx="minor">
-            <a:schemeClr val="lt1"/>
-          </a:fontRef>
-        </p:style>
-        <p:txBody>
-          <a:bodyPr rtlCol="0" anchor="ctr"/>
-          <a:lstStyle/>
-          <a:p>
-            <a:pPr algn="ctr"/>
+          <p:cNvPr id="2" name="TextBox 1"/>
+          <p:cNvSpPr txBox="1"/>
+          <p:nvPr/>
+        </p:nvSpPr>
+        <p:spPr>
+          <a:xfrm>
+            <a:off x="548640" y="420624"/>
+            <a:ext cx="10515600" cy="320040"/>
+          </a:xfrm>
+          <a:prstGeom prst="rect">
+            <a:avLst/>
+          </a:prstGeom>
+          <a:noFill/>
+        </p:spPr>
+        <p:txBody>
+          <a:bodyPr wrap="square" anchor="t">
+            <a:normAutofit/>
+          </a:bodyPr>
+          <a:lstStyle/>
+          <a:p>
+            <a:pPr algn="l"/>
+            <a:r>
+              <a:rPr sz="1300" b="1" i="0">
+                <a:solidFill>
+                  <a:srgbClr val="F4B634"/>
+                </a:solidFill>
+                <a:latin typeface="Arial"/>
+              </a:rPr>
+              <a:t>EXECUTIVE SUMMARY</a:t>
+            </a:r>
           </a:p>
         </p:txBody>
       </p:sp>
@@ -19626,29 +19617,29 @@
         </p:nvSpPr>
         <p:spPr>
           <a:xfrm>
-            <a:off x="411480" y="219456"/>
-            <a:ext cx="10058400" cy="274320"/>
-          </a:xfrm>
-          <a:prstGeom prst="rect">
-            <a:avLst/>
-          </a:prstGeom>
-          <a:noFill/>
-        </p:spPr>
-        <p:txBody>
-          <a:bodyPr wrap="square" anchor="t">
-            <a:normAutofit/>
-          </a:bodyPr>
-          <a:lstStyle/>
-          <a:p>
-            <a:pPr algn="l"/>
-            <a:r>
-              <a:rPr sz="1000" b="1" i="0">
-                <a:solidFill>
-                  <a:srgbClr val="F4B634"/>
-                </a:solidFill>
-                <a:latin typeface="Arial"/>
-              </a:rPr>
-              <a:t>EXECUTIVE SUMMARY — THE PROPOSAL ON ONE PAGE</a:t>
+            <a:off x="548640" y="749808"/>
+            <a:ext cx="10972800" cy="457200"/>
+          </a:xfrm>
+          <a:prstGeom prst="rect">
+            <a:avLst/>
+          </a:prstGeom>
+          <a:noFill/>
+        </p:spPr>
+        <p:txBody>
+          <a:bodyPr wrap="square" anchor="t">
+            <a:normAutofit/>
+          </a:bodyPr>
+          <a:lstStyle/>
+          <a:p>
+            <a:pPr algn="l"/>
+            <a:r>
+              <a:rPr sz="1800" b="1" i="0">
+                <a:solidFill>
+                  <a:srgbClr val="1F1942"/>
+                </a:solidFill>
+                <a:latin typeface="Arial"/>
+              </a:rPr>
+              <a:t>Appoint C&amp;W as your single point of control — you decide, we deliver</a:t>
             </a:r>
           </a:p>
         </p:txBody>
@@ -19661,41 +19652,29 @@
         </p:nvSpPr>
         <p:spPr>
           <a:xfrm>
-            <a:off x="411480" y="457200"/>
-            <a:ext cx="11155680" cy="868680"/>
-          </a:xfrm>
-          <a:prstGeom prst="rect">
-            <a:avLst/>
-          </a:prstGeom>
-          <a:noFill/>
-        </p:spPr>
-        <p:txBody>
-          <a:bodyPr wrap="square" anchor="t">
-            <a:normAutofit/>
-          </a:bodyPr>
-          <a:lstStyle/>
-          <a:p>
-            <a:pPr algn="l"/>
-            <a:r>
-              <a:rPr sz="2300" b="1" i="0">
-                <a:solidFill>
-                  <a:srgbClr val="1F1942"/>
-                </a:solidFill>
-                <a:latin typeface="Arial"/>
-              </a:rPr>
-              <a:t>Appoint C&amp;W as your single point of control: we deliver Paris Proof</a:t>
-            </a:r>
-          </a:p>
-          <a:p>
-            <a:pPr algn="l"/>
-            <a:r>
-              <a:rPr sz="2300" b="1" i="0">
-                <a:solidFill>
-                  <a:srgbClr val="1F1942"/>
-                </a:solidFill>
-                <a:latin typeface="Arial"/>
-              </a:rPr>
-              <a:t>with PwC fully aware and aligned — you decide, we deliver</a:t>
+            <a:off x="548640" y="6446520"/>
+            <a:ext cx="5486400" cy="274320"/>
+          </a:xfrm>
+          <a:prstGeom prst="rect">
+            <a:avLst/>
+          </a:prstGeom>
+          <a:noFill/>
+        </p:spPr>
+        <p:txBody>
+          <a:bodyPr wrap="square" anchor="t">
+            <a:normAutofit/>
+          </a:bodyPr>
+          <a:lstStyle/>
+          <a:p>
+            <a:pPr algn="l"/>
+            <a:r>
+              <a:rPr sz="800" b="0" i="0">
+                <a:solidFill>
+                  <a:srgbClr val="6B6467"/>
+                </a:solidFill>
+                <a:latin typeface="Arial"/>
+              </a:rPr>
+              <a:t>Cushman &amp; Wakefield  |  Corum A.M.  ·  Westgate I</a:t>
             </a:r>
           </a:p>
         </p:txBody>
@@ -19703,41 +19682,6 @@
       <p:sp>
         <p:nvSpPr>
           <p:cNvPr id="5" name="TextBox 4"/>
-          <p:cNvSpPr txBox="1"/>
-          <p:nvPr/>
-        </p:nvSpPr>
-        <p:spPr>
-          <a:xfrm>
-            <a:off x="411480" y="6446520"/>
-            <a:ext cx="5486400" cy="274320"/>
-          </a:xfrm>
-          <a:prstGeom prst="rect">
-            <a:avLst/>
-          </a:prstGeom>
-          <a:noFill/>
-        </p:spPr>
-        <p:txBody>
-          <a:bodyPr wrap="square" anchor="t">
-            <a:normAutofit/>
-          </a:bodyPr>
-          <a:lstStyle/>
-          <a:p>
-            <a:pPr algn="l"/>
-            <a:r>
-              <a:rPr sz="800" b="0" i="0">
-                <a:solidFill>
-                  <a:srgbClr val="6B6467"/>
-                </a:solidFill>
-                <a:latin typeface="Arial"/>
-              </a:rPr>
-              <a:t>CUSHMAN &amp; WAKEFIELD  |  CORUM A.M.  ·  WESTGATE I</a:t>
-            </a:r>
-          </a:p>
-        </p:txBody>
-      </p:sp>
-      <p:sp>
-        <p:nvSpPr>
-          <p:cNvPr id="6" name="TextBox 5"/>
           <p:cNvSpPr txBox="1"/>
           <p:nvPr/>
         </p:nvSpPr>
@@ -19772,7 +19716,7 @@
       </p:sp>
       <p:sp>
         <p:nvSpPr>
-          <p:cNvPr id="7" name="Rounded Rectangle 6"/>
+          <p:cNvPr id="6" name="Rounded Rectangle 5"/>
           <p:cNvSpPr/>
           <p:nvPr/>
         </p:nvSpPr>
@@ -19816,7 +19760,7 @@
       </p:sp>
       <p:sp>
         <p:nvSpPr>
-          <p:cNvPr id="8" name="TextBox 7"/>
+          <p:cNvPr id="7" name="TextBox 6"/>
           <p:cNvSpPr txBox="1"/>
           <p:nvPr/>
         </p:nvSpPr>
@@ -19851,14 +19795,235 @@
       </p:sp>
       <p:sp>
         <p:nvSpPr>
-          <p:cNvPr id="9" name="Rectangle 8"/>
+          <p:cNvPr id="8" name="Rectangle 7"/>
           <p:cNvSpPr/>
           <p:nvPr/>
         </p:nvSpPr>
         <p:spPr>
           <a:xfrm>
-            <a:off x="411480" y="1600200"/>
-            <a:ext cx="2103120" cy="932688"/>
+            <a:off x="548640" y="1600200"/>
+            <a:ext cx="41148" cy="3703320"/>
+          </a:xfrm>
+          <a:prstGeom prst="rect">
+            <a:avLst/>
+          </a:prstGeom>
+          <a:solidFill>
+            <a:srgbClr val="F4B634"/>
+          </a:solidFill>
+          <a:ln w="6350">
+            <a:solidFill>
+              <a:srgbClr val="E2DED6"/>
+            </a:solidFill>
+          </a:ln>
+          <a:effectLst/>
+        </p:spPr>
+        <p:style>
+          <a:lnRef idx="1">
+            <a:schemeClr val="accent1"/>
+          </a:lnRef>
+          <a:fillRef idx="3">
+            <a:schemeClr val="accent1"/>
+          </a:fillRef>
+          <a:effectRef idx="2">
+            <a:schemeClr val="accent1"/>
+          </a:effectRef>
+          <a:fontRef idx="minor">
+            <a:schemeClr val="lt1"/>
+          </a:fontRef>
+        </p:style>
+        <p:txBody>
+          <a:bodyPr rtlCol="0" anchor="ctr"/>
+          <a:lstStyle/>
+          <a:p>
+            <a:pPr algn="ctr"/>
+          </a:p>
+        </p:txBody>
+      </p:sp>
+      <p:sp>
+        <p:nvSpPr>
+          <p:cNvPr id="9" name="TextBox 8"/>
+          <p:cNvSpPr txBox="1"/>
+          <p:nvPr/>
+        </p:nvSpPr>
+        <p:spPr>
+          <a:xfrm>
+            <a:off x="777240" y="1627632"/>
+            <a:ext cx="4937760" cy="274320"/>
+          </a:xfrm>
+          <a:prstGeom prst="rect">
+            <a:avLst/>
+          </a:prstGeom>
+          <a:noFill/>
+        </p:spPr>
+        <p:txBody>
+          <a:bodyPr wrap="square" anchor="t">
+            <a:normAutofit/>
+          </a:bodyPr>
+          <a:lstStyle/>
+          <a:p>
+            <a:pPr algn="l"/>
+            <a:r>
+              <a:rPr sz="1200" b="1" i="0">
+                <a:solidFill>
+                  <a:srgbClr val="F4B634"/>
+                </a:solidFill>
+                <a:latin typeface="Arial"/>
+              </a:rPr>
+              <a:t>SITUATION</a:t>
+            </a:r>
+          </a:p>
+        </p:txBody>
+      </p:sp>
+      <p:sp>
+        <p:nvSpPr>
+          <p:cNvPr id="10" name="TextBox 9"/>
+          <p:cNvSpPr txBox="1"/>
+          <p:nvPr/>
+        </p:nvSpPr>
+        <p:spPr>
+          <a:xfrm>
+            <a:off x="777240" y="1938528"/>
+            <a:ext cx="5074920" cy="1371600"/>
+          </a:xfrm>
+          <a:prstGeom prst="rect">
+            <a:avLst/>
+          </a:prstGeom>
+          <a:noFill/>
+        </p:spPr>
+        <p:txBody>
+          <a:bodyPr wrap="square" anchor="t">
+            <a:normAutofit/>
+          </a:bodyPr>
+          <a:lstStyle/>
+          <a:p>
+            <a:pPr algn="l"/>
+            <a:r>
+              <a:rPr sz="1150" b="0" i="0">
+                <a:solidFill>
+                  <a:srgbClr val="1F1942"/>
+                </a:solidFill>
+                <a:latin typeface="Arial"/>
+              </a:rPr>
+              <a:t>Corum owns Westgate I — a prime 27,000 m² Amsterdam office, fully let to PwC — and has committed to make the building Paris Proof: a binding contractual obligation, not an ambition.</a:t>
+            </a:r>
+          </a:p>
+        </p:txBody>
+      </p:sp>
+      <p:sp>
+        <p:nvSpPr>
+          <p:cNvPr id="11" name="TextBox 10"/>
+          <p:cNvSpPr txBox="1"/>
+          <p:nvPr/>
+        </p:nvSpPr>
+        <p:spPr>
+          <a:xfrm>
+            <a:off x="777240" y="3520440"/>
+            <a:ext cx="4937760" cy="274320"/>
+          </a:xfrm>
+          <a:prstGeom prst="rect">
+            <a:avLst/>
+          </a:prstGeom>
+          <a:noFill/>
+        </p:spPr>
+        <p:txBody>
+          <a:bodyPr wrap="square" anchor="t">
+            <a:normAutofit/>
+          </a:bodyPr>
+          <a:lstStyle/>
+          <a:p>
+            <a:pPr algn="l"/>
+            <a:r>
+              <a:rPr sz="1200" b="1" i="0">
+                <a:solidFill>
+                  <a:srgbClr val="F4B634"/>
+                </a:solidFill>
+                <a:latin typeface="Arial"/>
+              </a:rPr>
+              <a:t>COMPLICATION</a:t>
+            </a:r>
+          </a:p>
+        </p:txBody>
+      </p:sp>
+      <p:sp>
+        <p:nvSpPr>
+          <p:cNvPr id="12" name="TextBox 11"/>
+          <p:cNvSpPr txBox="1"/>
+          <p:nvPr/>
+        </p:nvSpPr>
+        <p:spPr>
+          <a:xfrm>
+            <a:off x="777240" y="3831336"/>
+            <a:ext cx="5074920" cy="1463040"/>
+          </a:xfrm>
+          <a:prstGeom prst="rect">
+            <a:avLst/>
+          </a:prstGeom>
+          <a:noFill/>
+        </p:spPr>
+        <p:txBody>
+          <a:bodyPr wrap="square" anchor="t">
+            <a:normAutofit/>
+          </a:bodyPr>
+          <a:lstStyle/>
+          <a:p>
+            <a:pPr algn="l"/>
+            <a:r>
+              <a:rPr sz="1150" b="0" i="0">
+                <a:solidFill>
+                  <a:srgbClr val="1F1942"/>
+                </a:solidFill>
+                <a:latin typeface="Arial"/>
+              </a:rPr>
+              <a:t>The upgrade must happen inside a live, occupied building without losing PwC's confidence, on a fixed budget and against a hard deadline — steered from a distance by an investor, not a builder.</a:t>
+            </a:r>
+          </a:p>
+        </p:txBody>
+      </p:sp>
+      <p:sp>
+        <p:nvSpPr>
+          <p:cNvPr id="13" name="TextBox 12"/>
+          <p:cNvSpPr txBox="1"/>
+          <p:nvPr/>
+        </p:nvSpPr>
+        <p:spPr>
+          <a:xfrm>
+            <a:off x="6355080" y="1600200"/>
+            <a:ext cx="5394960" cy="1828800"/>
+          </a:xfrm>
+          <a:prstGeom prst="rect">
+            <a:avLst/>
+          </a:prstGeom>
+          <a:noFill/>
+        </p:spPr>
+        <p:txBody>
+          <a:bodyPr wrap="square" anchor="ctr">
+            <a:normAutofit/>
+          </a:bodyPr>
+          <a:lstStyle/>
+          <a:p>
+            <a:pPr algn="l"/>
+            <a:r>
+              <a:rPr sz="1900" b="0" i="1">
+                <a:solidFill>
+                  <a:srgbClr val="F4B634"/>
+                </a:solidFill>
+                <a:latin typeface="Georgia"/>
+              </a:rPr>
+              <a:t>How does Corum deliver Paris Proof and protect the PwC tenancy and the asset's value — without being pulled into day-to-day management in the Netherlands?</a:t>
+            </a:r>
+          </a:p>
+        </p:txBody>
+      </p:sp>
+      <p:sp>
+        <p:nvSpPr>
+          <p:cNvPr id="14" name="Rectangle 13"/>
+          <p:cNvSpPr/>
+          <p:nvPr/>
+        </p:nvSpPr>
+        <p:spPr>
+          <a:xfrm>
+            <a:off x="6355080" y="3657600"/>
+            <a:ext cx="5394960" cy="1783080"/>
           </a:xfrm>
           <a:prstGeom prst="rect">
             <a:avLst/>
@@ -19897,602 +20062,70 @@
       </p:sp>
       <p:sp>
         <p:nvSpPr>
-          <p:cNvPr id="10" name="TextBox 9"/>
-          <p:cNvSpPr txBox="1"/>
-          <p:nvPr/>
-        </p:nvSpPr>
-        <p:spPr>
-          <a:xfrm>
-            <a:off x="411480" y="1673352"/>
-            <a:ext cx="2103120" cy="457200"/>
-          </a:xfrm>
-          <a:prstGeom prst="rect">
-            <a:avLst/>
-          </a:prstGeom>
-          <a:noFill/>
-        </p:spPr>
-        <p:txBody>
-          <a:bodyPr wrap="square" anchor="ctr">
-            <a:normAutofit/>
-          </a:bodyPr>
-          <a:lstStyle/>
-          <a:p>
-            <a:pPr algn="ctr"/>
-            <a:r>
-              <a:rPr sz="1300" b="1" i="0">
+          <p:cNvPr id="15" name="TextBox 14"/>
+          <p:cNvSpPr txBox="1"/>
+          <p:nvPr/>
+        </p:nvSpPr>
+        <p:spPr>
+          <a:xfrm>
+            <a:off x="6583680" y="3822191"/>
+            <a:ext cx="5029200" cy="274320"/>
+          </a:xfrm>
+          <a:prstGeom prst="rect">
+            <a:avLst/>
+          </a:prstGeom>
+          <a:noFill/>
+        </p:spPr>
+        <p:txBody>
+          <a:bodyPr wrap="square" anchor="t">
+            <a:normAutofit/>
+          </a:bodyPr>
+          <a:lstStyle/>
+          <a:p>
+            <a:pPr algn="l"/>
+            <a:r>
+              <a:rPr sz="1200" b="1" i="0">
+                <a:solidFill>
+                  <a:srgbClr val="F4B634"/>
+                </a:solidFill>
+                <a:latin typeface="Arial"/>
+              </a:rPr>
+              <a:t>OUR ANSWER</a:t>
+            </a:r>
+          </a:p>
+        </p:txBody>
+      </p:sp>
+      <p:sp>
+        <p:nvSpPr>
+          <p:cNvPr id="16" name="TextBox 15"/>
+          <p:cNvSpPr txBox="1"/>
+          <p:nvPr/>
+        </p:nvSpPr>
+        <p:spPr>
+          <a:xfrm>
+            <a:off x="6583680" y="4151376"/>
+            <a:ext cx="4983480" cy="1188720"/>
+          </a:xfrm>
+          <a:prstGeom prst="rect">
+            <a:avLst/>
+          </a:prstGeom>
+          <a:noFill/>
+        </p:spPr>
+        <p:txBody>
+          <a:bodyPr wrap="square" anchor="t">
+            <a:normAutofit/>
+          </a:bodyPr>
+          <a:lstStyle/>
+          <a:p>
+            <a:pPr algn="l"/>
+            <a:r>
+              <a:rPr sz="1150" b="0" i="0">
                 <a:solidFill>
                   <a:srgbClr val="FFFFFF"/>
                 </a:solidFill>
                 <a:latin typeface="Arial"/>
               </a:rPr>
-              <a:t>SITUATION</a:t>
-            </a:r>
-          </a:p>
-        </p:txBody>
-      </p:sp>
-      <p:sp>
-        <p:nvSpPr>
-          <p:cNvPr id="11" name="Rectangle 10"/>
-          <p:cNvSpPr/>
-          <p:nvPr/>
-        </p:nvSpPr>
-        <p:spPr>
-          <a:xfrm>
-            <a:off x="2560320" y="1600200"/>
-            <a:ext cx="9189720" cy="932688"/>
-          </a:xfrm>
-          <a:prstGeom prst="rect">
-            <a:avLst/>
-          </a:prstGeom>
-          <a:solidFill>
-            <a:srgbClr val="F4EFE6"/>
-          </a:solidFill>
-          <a:ln w="9525">
-            <a:solidFill>
-              <a:srgbClr val="6B6467"/>
-            </a:solidFill>
-          </a:ln>
-          <a:effectLst/>
-        </p:spPr>
-        <p:style>
-          <a:lnRef idx="1">
-            <a:schemeClr val="accent1"/>
-          </a:lnRef>
-          <a:fillRef idx="3">
-            <a:schemeClr val="accent1"/>
-          </a:fillRef>
-          <a:effectRef idx="2">
-            <a:schemeClr val="accent1"/>
-          </a:effectRef>
-          <a:fontRef idx="minor">
-            <a:schemeClr val="lt1"/>
-          </a:fontRef>
-        </p:style>
-        <p:txBody>
-          <a:bodyPr rtlCol="0" anchor="ctr"/>
-          <a:lstStyle/>
-          <a:p>
-            <a:pPr algn="ctr"/>
-          </a:p>
-        </p:txBody>
-      </p:sp>
-      <p:sp>
-        <p:nvSpPr>
-          <p:cNvPr id="12" name="TextBox 11"/>
-          <p:cNvSpPr txBox="1"/>
-          <p:nvPr/>
-        </p:nvSpPr>
-        <p:spPr>
-          <a:xfrm>
-            <a:off x="2743200" y="1691640"/>
-            <a:ext cx="8869680" cy="749808"/>
-          </a:xfrm>
-          <a:prstGeom prst="rect">
-            <a:avLst/>
-          </a:prstGeom>
-          <a:noFill/>
-        </p:spPr>
-        <p:txBody>
-          <a:bodyPr wrap="square" anchor="ctr">
-            <a:normAutofit/>
-          </a:bodyPr>
-          <a:lstStyle/>
-          <a:p>
-            <a:pPr algn="l"/>
-            <a:r>
-              <a:rPr sz="1150" b="0" i="0">
-                <a:solidFill>
-                  <a:srgbClr val="1F1942"/>
-                </a:solidFill>
-                <a:latin typeface="Arial"/>
-              </a:rPr>
-              <a:t>Corum owns Westgate I — a prime 27,000 m² Amsterdam office, fully let to PwC — and has committed to make the building Paris Proof. This is a binding contractual obligation, not an ambition.</a:t>
-            </a:r>
-          </a:p>
-        </p:txBody>
-      </p:sp>
-      <p:sp>
-        <p:nvSpPr>
-          <p:cNvPr id="13" name="Rectangle 12"/>
-          <p:cNvSpPr/>
-          <p:nvPr/>
-        </p:nvSpPr>
-        <p:spPr>
-          <a:xfrm>
-            <a:off x="411480" y="2642616"/>
-            <a:ext cx="2103120" cy="1170432"/>
-          </a:xfrm>
-          <a:prstGeom prst="rect">
-            <a:avLst/>
-          </a:prstGeom>
-          <a:solidFill>
-            <a:srgbClr val="1F1942"/>
-          </a:solidFill>
-          <a:ln w="6350">
-            <a:solidFill>
-              <a:srgbClr val="E2DED6"/>
-            </a:solidFill>
-          </a:ln>
-          <a:effectLst/>
-        </p:spPr>
-        <p:style>
-          <a:lnRef idx="1">
-            <a:schemeClr val="accent1"/>
-          </a:lnRef>
-          <a:fillRef idx="3">
-            <a:schemeClr val="accent1"/>
-          </a:fillRef>
-          <a:effectRef idx="2">
-            <a:schemeClr val="accent1"/>
-          </a:effectRef>
-          <a:fontRef idx="minor">
-            <a:schemeClr val="lt1"/>
-          </a:fontRef>
-        </p:style>
-        <p:txBody>
-          <a:bodyPr rtlCol="0" anchor="ctr"/>
-          <a:lstStyle/>
-          <a:p>
-            <a:pPr algn="ctr"/>
-          </a:p>
-        </p:txBody>
-      </p:sp>
-      <p:sp>
-        <p:nvSpPr>
-          <p:cNvPr id="14" name="TextBox 13"/>
-          <p:cNvSpPr txBox="1"/>
-          <p:nvPr/>
-        </p:nvSpPr>
-        <p:spPr>
-          <a:xfrm>
-            <a:off x="411480" y="2715768"/>
-            <a:ext cx="2103120" cy="457200"/>
-          </a:xfrm>
-          <a:prstGeom prst="rect">
-            <a:avLst/>
-          </a:prstGeom>
-          <a:noFill/>
-        </p:spPr>
-        <p:txBody>
-          <a:bodyPr wrap="square" anchor="ctr">
-            <a:normAutofit/>
-          </a:bodyPr>
-          <a:lstStyle/>
-          <a:p>
-            <a:pPr algn="ctr"/>
-            <a:r>
-              <a:rPr sz="1300" b="1" i="0">
-                <a:solidFill>
-                  <a:srgbClr val="FFFFFF"/>
-                </a:solidFill>
-                <a:latin typeface="Arial"/>
-              </a:rPr>
-              <a:t>COMPLICATION</a:t>
-            </a:r>
-          </a:p>
-        </p:txBody>
-      </p:sp>
-      <p:sp>
-        <p:nvSpPr>
-          <p:cNvPr id="15" name="Rectangle 14"/>
-          <p:cNvSpPr/>
-          <p:nvPr/>
-        </p:nvSpPr>
-        <p:spPr>
-          <a:xfrm>
-            <a:off x="2560320" y="2642616"/>
-            <a:ext cx="9189720" cy="1170432"/>
-          </a:xfrm>
-          <a:prstGeom prst="rect">
-            <a:avLst/>
-          </a:prstGeom>
-          <a:solidFill>
-            <a:srgbClr val="F4EFE6"/>
-          </a:solidFill>
-          <a:ln w="9525">
-            <a:solidFill>
-              <a:srgbClr val="6B6467"/>
-            </a:solidFill>
-          </a:ln>
-          <a:effectLst/>
-        </p:spPr>
-        <p:style>
-          <a:lnRef idx="1">
-            <a:schemeClr val="accent1"/>
-          </a:lnRef>
-          <a:fillRef idx="3">
-            <a:schemeClr val="accent1"/>
-          </a:fillRef>
-          <a:effectRef idx="2">
-            <a:schemeClr val="accent1"/>
-          </a:effectRef>
-          <a:fontRef idx="minor">
-            <a:schemeClr val="lt1"/>
-          </a:fontRef>
-        </p:style>
-        <p:txBody>
-          <a:bodyPr rtlCol="0" anchor="ctr"/>
-          <a:lstStyle/>
-          <a:p>
-            <a:pPr algn="ctr"/>
-          </a:p>
-        </p:txBody>
-      </p:sp>
-      <p:sp>
-        <p:nvSpPr>
-          <p:cNvPr id="16" name="TextBox 15"/>
-          <p:cNvSpPr txBox="1"/>
-          <p:nvPr/>
-        </p:nvSpPr>
-        <p:spPr>
-          <a:xfrm>
-            <a:off x="2743200" y="2734056"/>
-            <a:ext cx="8869680" cy="987552"/>
-          </a:xfrm>
-          <a:prstGeom prst="rect">
-            <a:avLst/>
-          </a:prstGeom>
-          <a:noFill/>
-        </p:spPr>
-        <p:txBody>
-          <a:bodyPr wrap="square" anchor="ctr">
-            <a:normAutofit/>
-          </a:bodyPr>
-          <a:lstStyle/>
-          <a:p>
-            <a:pPr algn="l"/>
-            <a:r>
-              <a:rPr sz="1150" b="0" i="0">
-                <a:solidFill>
-                  <a:srgbClr val="1F1942"/>
-                </a:solidFill>
-                <a:latin typeface="Arial"/>
-              </a:rPr>
-              <a:t>The upgrade must happen inside a live, occupied building without losing PwC's confidence, within a fixed budget and against a hard sustainability deadline — while being steered from a distance by an owner whose core business is investment, not Dutch construction management.</a:t>
-            </a:r>
-          </a:p>
-        </p:txBody>
-      </p:sp>
-      <p:sp>
-        <p:nvSpPr>
-          <p:cNvPr id="17" name="Rectangle 16"/>
-          <p:cNvSpPr/>
-          <p:nvPr/>
-        </p:nvSpPr>
-        <p:spPr>
-          <a:xfrm>
-            <a:off x="411480" y="3922776"/>
-            <a:ext cx="2103120" cy="932688"/>
-          </a:xfrm>
-          <a:prstGeom prst="rect">
-            <a:avLst/>
-          </a:prstGeom>
-          <a:solidFill>
-            <a:srgbClr val="2A2250"/>
-          </a:solidFill>
-          <a:ln w="6350">
-            <a:solidFill>
-              <a:srgbClr val="E2DED6"/>
-            </a:solidFill>
-          </a:ln>
-          <a:effectLst/>
-        </p:spPr>
-        <p:style>
-          <a:lnRef idx="1">
-            <a:schemeClr val="accent1"/>
-          </a:lnRef>
-          <a:fillRef idx="3">
-            <a:schemeClr val="accent1"/>
-          </a:fillRef>
-          <a:effectRef idx="2">
-            <a:schemeClr val="accent1"/>
-          </a:effectRef>
-          <a:fontRef idx="minor">
-            <a:schemeClr val="lt1"/>
-          </a:fontRef>
-        </p:style>
-        <p:txBody>
-          <a:bodyPr rtlCol="0" anchor="ctr"/>
-          <a:lstStyle/>
-          <a:p>
-            <a:pPr algn="ctr"/>
-          </a:p>
-        </p:txBody>
-      </p:sp>
-      <p:sp>
-        <p:nvSpPr>
-          <p:cNvPr id="18" name="TextBox 17"/>
-          <p:cNvSpPr txBox="1"/>
-          <p:nvPr/>
-        </p:nvSpPr>
-        <p:spPr>
-          <a:xfrm>
-            <a:off x="411480" y="3995928"/>
-            <a:ext cx="2103120" cy="457200"/>
-          </a:xfrm>
-          <a:prstGeom prst="rect">
-            <a:avLst/>
-          </a:prstGeom>
-          <a:noFill/>
-        </p:spPr>
-        <p:txBody>
-          <a:bodyPr wrap="square" anchor="ctr">
-            <a:normAutofit/>
-          </a:bodyPr>
-          <a:lstStyle/>
-          <a:p>
-            <a:pPr algn="ctr"/>
-            <a:r>
-              <a:rPr sz="1300" b="1" i="0">
-                <a:solidFill>
-                  <a:srgbClr val="FFFFFF"/>
-                </a:solidFill>
-                <a:latin typeface="Arial"/>
-              </a:rPr>
-              <a:t>QUESTION</a:t>
-            </a:r>
-          </a:p>
-        </p:txBody>
-      </p:sp>
-      <p:sp>
-        <p:nvSpPr>
-          <p:cNvPr id="19" name="Rectangle 18"/>
-          <p:cNvSpPr/>
-          <p:nvPr/>
-        </p:nvSpPr>
-        <p:spPr>
-          <a:xfrm>
-            <a:off x="2560320" y="3922776"/>
-            <a:ext cx="9189720" cy="932688"/>
-          </a:xfrm>
-          <a:prstGeom prst="rect">
-            <a:avLst/>
-          </a:prstGeom>
-          <a:solidFill>
-            <a:srgbClr val="FFFFFF"/>
-          </a:solidFill>
-          <a:ln w="9525">
-            <a:solidFill>
-              <a:srgbClr val="2A2250"/>
-            </a:solidFill>
-          </a:ln>
-          <a:effectLst/>
-        </p:spPr>
-        <p:style>
-          <a:lnRef idx="1">
-            <a:schemeClr val="accent1"/>
-          </a:lnRef>
-          <a:fillRef idx="3">
-            <a:schemeClr val="accent1"/>
-          </a:fillRef>
-          <a:effectRef idx="2">
-            <a:schemeClr val="accent1"/>
-          </a:effectRef>
-          <a:fontRef idx="minor">
-            <a:schemeClr val="lt1"/>
-          </a:fontRef>
-        </p:style>
-        <p:txBody>
-          <a:bodyPr rtlCol="0" anchor="ctr"/>
-          <a:lstStyle/>
-          <a:p>
-            <a:pPr algn="ctr"/>
-          </a:p>
-        </p:txBody>
-      </p:sp>
-      <p:sp>
-        <p:nvSpPr>
-          <p:cNvPr id="20" name="TextBox 19"/>
-          <p:cNvSpPr txBox="1"/>
-          <p:nvPr/>
-        </p:nvSpPr>
-        <p:spPr>
-          <a:xfrm>
-            <a:off x="2743200" y="4014216"/>
-            <a:ext cx="8869680" cy="749808"/>
-          </a:xfrm>
-          <a:prstGeom prst="rect">
-            <a:avLst/>
-          </a:prstGeom>
-          <a:noFill/>
-        </p:spPr>
-        <p:txBody>
-          <a:bodyPr wrap="square" anchor="ctr">
-            <a:normAutofit/>
-          </a:bodyPr>
-          <a:lstStyle/>
-          <a:p>
-            <a:pPr algn="l"/>
-            <a:r>
-              <a:rPr sz="1150" b="1" i="0">
-                <a:solidFill>
-                  <a:srgbClr val="1F1942"/>
-                </a:solidFill>
-                <a:latin typeface="Arial"/>
-              </a:rPr>
-              <a:t>How does Corum deliver Paris Proof and protect both the PwC tenancy and the asset's value, without being pulled into day-to-day tenant and project management in the Netherlands?</a:t>
-            </a:r>
-          </a:p>
-        </p:txBody>
-      </p:sp>
-      <p:sp>
-        <p:nvSpPr>
-          <p:cNvPr id="21" name="Rectangle 20"/>
-          <p:cNvSpPr/>
-          <p:nvPr/>
-        </p:nvSpPr>
-        <p:spPr>
-          <a:xfrm>
-            <a:off x="411480" y="4965192"/>
-            <a:ext cx="2103120" cy="1170432"/>
-          </a:xfrm>
-          <a:prstGeom prst="rect">
-            <a:avLst/>
-          </a:prstGeom>
-          <a:solidFill>
-            <a:srgbClr val="2A2250"/>
-          </a:solidFill>
-          <a:ln w="6350">
-            <a:solidFill>
-              <a:srgbClr val="E2DED6"/>
-            </a:solidFill>
-          </a:ln>
-          <a:effectLst/>
-        </p:spPr>
-        <p:style>
-          <a:lnRef idx="1">
-            <a:schemeClr val="accent1"/>
-          </a:lnRef>
-          <a:fillRef idx="3">
-            <a:schemeClr val="accent1"/>
-          </a:fillRef>
-          <a:effectRef idx="2">
-            <a:schemeClr val="accent1"/>
-          </a:effectRef>
-          <a:fontRef idx="minor">
-            <a:schemeClr val="lt1"/>
-          </a:fontRef>
-        </p:style>
-        <p:txBody>
-          <a:bodyPr rtlCol="0" anchor="ctr"/>
-          <a:lstStyle/>
-          <a:p>
-            <a:pPr algn="ctr"/>
-          </a:p>
-        </p:txBody>
-      </p:sp>
-      <p:sp>
-        <p:nvSpPr>
-          <p:cNvPr id="22" name="TextBox 21"/>
-          <p:cNvSpPr txBox="1"/>
-          <p:nvPr/>
-        </p:nvSpPr>
-        <p:spPr>
-          <a:xfrm>
-            <a:off x="411480" y="5038344"/>
-            <a:ext cx="2103120" cy="457200"/>
-          </a:xfrm>
-          <a:prstGeom prst="rect">
-            <a:avLst/>
-          </a:prstGeom>
-          <a:noFill/>
-        </p:spPr>
-        <p:txBody>
-          <a:bodyPr wrap="square" anchor="ctr">
-            <a:normAutofit/>
-          </a:bodyPr>
-          <a:lstStyle/>
-          <a:p>
-            <a:pPr algn="ctr"/>
-            <a:r>
-              <a:rPr sz="1300" b="1" i="0">
-                <a:solidFill>
-                  <a:srgbClr val="FFFFFF"/>
-                </a:solidFill>
-                <a:latin typeface="Arial"/>
-              </a:rPr>
-              <a:t>ANSWER</a:t>
-            </a:r>
-          </a:p>
-        </p:txBody>
-      </p:sp>
-      <p:sp>
-        <p:nvSpPr>
-          <p:cNvPr id="23" name="Rectangle 22"/>
-          <p:cNvSpPr/>
-          <p:nvPr/>
-        </p:nvSpPr>
-        <p:spPr>
-          <a:xfrm>
-            <a:off x="2560320" y="4965192"/>
-            <a:ext cx="9189720" cy="1170432"/>
-          </a:xfrm>
-          <a:prstGeom prst="rect">
-            <a:avLst/>
-          </a:prstGeom>
-          <a:solidFill>
-            <a:srgbClr val="FFFFFF"/>
-          </a:solidFill>
-          <a:ln w="9525">
-            <a:solidFill>
-              <a:srgbClr val="2A2250"/>
-            </a:solidFill>
-          </a:ln>
-          <a:effectLst/>
-        </p:spPr>
-        <p:style>
-          <a:lnRef idx="1">
-            <a:schemeClr val="accent1"/>
-          </a:lnRef>
-          <a:fillRef idx="3">
-            <a:schemeClr val="accent1"/>
-          </a:fillRef>
-          <a:effectRef idx="2">
-            <a:schemeClr val="accent1"/>
-          </a:effectRef>
-          <a:fontRef idx="minor">
-            <a:schemeClr val="lt1"/>
-          </a:fontRef>
-        </p:style>
-        <p:txBody>
-          <a:bodyPr rtlCol="0" anchor="ctr"/>
-          <a:lstStyle/>
-          <a:p>
-            <a:pPr algn="ctr"/>
-          </a:p>
-        </p:txBody>
-      </p:sp>
-      <p:sp>
-        <p:nvSpPr>
-          <p:cNvPr id="24" name="TextBox 23"/>
-          <p:cNvSpPr txBox="1"/>
-          <p:nvPr/>
-        </p:nvSpPr>
-        <p:spPr>
-          <a:xfrm>
-            <a:off x="2743200" y="5056632"/>
-            <a:ext cx="8869680" cy="987552"/>
-          </a:xfrm>
-          <a:prstGeom prst="rect">
-            <a:avLst/>
-          </a:prstGeom>
-          <a:noFill/>
-        </p:spPr>
-        <p:txBody>
-          <a:bodyPr wrap="square" anchor="ctr">
-            <a:normAutofit/>
-          </a:bodyPr>
-          <a:lstStyle/>
-          <a:p>
-            <a:pPr algn="l"/>
-            <a:r>
-              <a:rPr sz="1150" b="1" i="0">
-                <a:solidFill>
-                  <a:srgbClr val="1F1942"/>
-                </a:solidFill>
-                <a:latin typeface="Arial"/>
-              </a:rPr>
-              <a:t>Appoint Cushman &amp; Wakefield as your single point of control. We deliver the Paris Proof transformation end-to-end and keep PwC fully aware and aligned throughout — from a low-commitment preparatory phase to verified handover. One contact, one report, no surprises.</a:t>
+              <a:t>Appoint Cushman &amp; Wakefield as your single point of control. We deliver the transformation end-to-end and keep PwC fully aware and aligned — from a low-commitment preparatory phase to verified handover. One contact, one report, no surprises.</a:t>
             </a:r>
           </a:p>
         </p:txBody>

</xml_diff>